<commit_message>
docs(demos): redesign slideshow decks
</commit_message>
<xml_diff>
--- a/docs/source/AGILAB_Flight_First_Proof_Slides.pptx
+++ b/docs/source/AGILAB_Flight_First_Proof_Slides.pptx
@@ -3087,7 +3087,7 @@
     <p:bg>
       <p:bgPr>
         <a:solidFill>
-          <a:srgbClr val="F7F3EB"/>
+          <a:srgbClr val="0B131D"/>
         </a:solidFill>
         <a:effectLst/>
       </p:bgPr>
@@ -3101,73 +3101,23 @@
       <p:grpSpPr/>
       <p:sp>
         <p:nvSpPr>
-          <p:cNvPr id="2" name="TextBox 1"/>
-          <p:cNvSpPr txBox="1"/>
-          <p:nvPr/>
-        </p:nvSpPr>
-        <p:spPr>
-          <a:xfrm>
-            <a:off x="640080" y="502920"/>
-            <a:ext cx="10972800" cy="1005840"/>
+          <p:cNvPr id="2" name="Rectangle 1"/>
+          <p:cNvSpPr/>
+          <p:nvPr/>
+        </p:nvSpPr>
+        <p:spPr>
+          <a:xfrm>
+            <a:off x="0" y="0"/>
+            <a:ext cx="12191695" cy="146304"/>
           </a:xfrm>
           <a:prstGeom prst="rect">
             <a:avLst/>
           </a:prstGeom>
-          <a:noFill/>
-        </p:spPr>
-        <p:txBody>
-          <a:bodyPr wrap="none">
-            <a:spAutoFit/>
-          </a:bodyPr>
-          <a:lstStyle/>
-          <a:p>
-            <a:r>
-              <a:rPr sz="2800" b="1">
-                <a:solidFill>
-                  <a:srgbClr val="2D5C7A"/>
-                </a:solidFill>
-              </a:rPr>
-              <a:t>AGILAB First Proof</a:t>
-            </a:r>
-          </a:p>
-          <a:p>
-            <a:pPr>
-              <a:spcBef>
-                <a:spcPts val="400"/>
-              </a:spcBef>
-            </a:pPr>
-            <a:r>
-              <a:rPr sz="1400">
-                <a:solidFill>
-                  <a:srgbClr val="5B6268"/>
-                </a:solidFill>
-              </a:rPr>
-              <a:t>Slideshow companion for the newcomer-safe `flight_project` story</a:t>
-            </a:r>
-          </a:p>
-        </p:txBody>
-      </p:sp>
-      <p:sp>
-        <p:nvSpPr>
-          <p:cNvPr id="3" name="Rounded Rectangle 2"/>
-          <p:cNvSpPr/>
-          <p:nvPr/>
-        </p:nvSpPr>
-        <p:spPr>
-          <a:xfrm>
-            <a:off x="640080" y="1463040"/>
-            <a:ext cx="10972800" cy="4480560"/>
-          </a:xfrm>
-          <a:prstGeom prst="roundRect">
-            <a:avLst/>
-          </a:prstGeom>
-          <a:solidFill>
-            <a:srgbClr val="FFFBF5"/>
-          </a:solidFill>
-          <a:ln w="19050">
-            <a:solidFill>
-              <a:srgbClr val="DCCEBF"/>
-            </a:solidFill>
+          <a:solidFill>
+            <a:srgbClr val="E86E3A"/>
+          </a:solidFill>
+          <a:ln>
+            <a:noFill/>
           </a:ln>
         </p:spPr>
         <p:style>
@@ -3194,14 +3144,810 @@
       </p:sp>
       <p:sp>
         <p:nvSpPr>
-          <p:cNvPr id="4" name="TextBox 3"/>
+          <p:cNvPr id="3" name="Oval 2"/>
+          <p:cNvSpPr/>
+          <p:nvPr/>
+        </p:nvSpPr>
+        <p:spPr>
+          <a:xfrm>
+            <a:off x="10607040" y="-731520"/>
+            <a:ext cx="2560320" cy="2560320"/>
+          </a:xfrm>
+          <a:prstGeom prst="ellipse">
+            <a:avLst/>
+          </a:prstGeom>
+          <a:solidFill>
+            <a:srgbClr val="12202D"/>
+          </a:solidFill>
+          <a:ln>
+            <a:noFill/>
+          </a:ln>
+        </p:spPr>
+        <p:style>
+          <a:lnRef idx="1">
+            <a:schemeClr val="accent1"/>
+          </a:lnRef>
+          <a:fillRef idx="3">
+            <a:schemeClr val="accent1"/>
+          </a:fillRef>
+          <a:effectRef idx="2">
+            <a:schemeClr val="accent1"/>
+          </a:effectRef>
+          <a:fontRef idx="minor">
+            <a:schemeClr val="lt1"/>
+          </a:fontRef>
+        </p:style>
+        <p:txBody>
+          <a:bodyPr rtlCol="0" anchor="ctr"/>
+          <a:lstStyle/>
+          <a:p>
+            <a:pPr algn="ctr"/>
+          </a:p>
+        </p:txBody>
+      </p:sp>
+      <p:sp>
+        <p:nvSpPr>
+          <p:cNvPr id="4" name="Oval 3"/>
+          <p:cNvSpPr/>
+          <p:nvPr/>
+        </p:nvSpPr>
+        <p:spPr>
+          <a:xfrm>
+            <a:off x="9966960" y="5120640"/>
+            <a:ext cx="2103120" cy="2103120"/>
+          </a:xfrm>
+          <a:prstGeom prst="ellipse">
+            <a:avLst/>
+          </a:prstGeom>
+          <a:solidFill>
+            <a:srgbClr val="1C2D3D"/>
+          </a:solidFill>
+          <a:ln>
+            <a:noFill/>
+          </a:ln>
+        </p:spPr>
+        <p:style>
+          <a:lnRef idx="1">
+            <a:schemeClr val="accent1"/>
+          </a:lnRef>
+          <a:fillRef idx="3">
+            <a:schemeClr val="accent1"/>
+          </a:fillRef>
+          <a:effectRef idx="2">
+            <a:schemeClr val="accent1"/>
+          </a:effectRef>
+          <a:fontRef idx="minor">
+            <a:schemeClr val="lt1"/>
+          </a:fontRef>
+        </p:style>
+        <p:txBody>
+          <a:bodyPr rtlCol="0" anchor="ctr"/>
+          <a:lstStyle/>
+          <a:p>
+            <a:pPr algn="ctr"/>
+          </a:p>
+        </p:txBody>
+      </p:sp>
+      <p:sp>
+        <p:nvSpPr>
+          <p:cNvPr id="5" name="TextBox 4"/>
           <p:cNvSpPr txBox="1"/>
           <p:nvPr/>
         </p:nvSpPr>
         <p:spPr>
           <a:xfrm>
-            <a:off x="914400" y="1828800"/>
-            <a:ext cx="10424160" cy="3474720"/>
+            <a:off x="777240" y="658368"/>
+            <a:ext cx="4114800" cy="228600"/>
+          </a:xfrm>
+          <a:prstGeom prst="rect">
+            <a:avLst/>
+          </a:prstGeom>
+          <a:noFill/>
+        </p:spPr>
+        <p:txBody>
+          <a:bodyPr wrap="none">
+            <a:spAutoFit/>
+          </a:bodyPr>
+          <a:lstStyle/>
+          <a:p>
+            <a:pPr algn="l">
+              <a:spcBef>
+                <a:spcPts val="0"/>
+              </a:spcBef>
+              <a:spcAft>
+                <a:spcPts val="0"/>
+              </a:spcAft>
+            </a:pPr>
+            <a:r>
+              <a:rPr sz="1000" b="1">
+                <a:solidFill>
+                  <a:srgbClr val="54B9D6"/>
+                </a:solidFill>
+                <a:latin typeface="Aptos"/>
+              </a:rPr>
+              <a:t>NEWCOMER-SAFE PROOF</a:t>
+            </a:r>
+          </a:p>
+        </p:txBody>
+      </p:sp>
+      <p:sp>
+        <p:nvSpPr>
+          <p:cNvPr id="6" name="TextBox 5"/>
+          <p:cNvSpPr txBox="1"/>
+          <p:nvPr/>
+        </p:nvSpPr>
+        <p:spPr>
+          <a:xfrm>
+            <a:off x="777240" y="868680"/>
+            <a:ext cx="4754880" cy="1371600"/>
+          </a:xfrm>
+          <a:prstGeom prst="rect">
+            <a:avLst/>
+          </a:prstGeom>
+          <a:noFill/>
+        </p:spPr>
+        <p:txBody>
+          <a:bodyPr wrap="square" anchor="t">
+            <a:spAutoFit/>
+          </a:bodyPr>
+          <a:lstStyle/>
+          <a:p>
+            <a:pPr algn="l">
+              <a:spcAft>
+                <a:spcPts val="300"/>
+              </a:spcAft>
+            </a:pPr>
+            <a:r>
+              <a:rPr sz="2800" b="1">
+                <a:solidFill>
+                  <a:srgbClr val="F4F0EB"/>
+                </a:solidFill>
+                <a:latin typeface="Aptos Display"/>
+              </a:rPr>
+              <a:t>AGILAB First Proof</a:t>
+            </a:r>
+          </a:p>
+          <a:p>
+            <a:pPr algn="l">
+              <a:spcBef>
+                <a:spcPts val="200"/>
+              </a:spcBef>
+            </a:pPr>
+            <a:r>
+              <a:rPr sz="1300" b="0">
+                <a:solidFill>
+                  <a:srgbClr val="ABB7C4"/>
+                </a:solidFill>
+                <a:latin typeface="Aptos"/>
+              </a:rPr>
+              <a:t>Slideshow companion for the newcomer-safe `flight_project` story</a:t>
+            </a:r>
+          </a:p>
+        </p:txBody>
+      </p:sp>
+      <p:sp>
+        <p:nvSpPr>
+          <p:cNvPr id="7" name="Rounded Rectangle 6"/>
+          <p:cNvSpPr/>
+          <p:nvPr/>
+        </p:nvSpPr>
+        <p:spPr>
+          <a:xfrm>
+            <a:off x="841248" y="2313432"/>
+            <a:ext cx="1691640" cy="1463040"/>
+          </a:xfrm>
+          <a:prstGeom prst="roundRect">
+            <a:avLst/>
+          </a:prstGeom>
+          <a:solidFill>
+            <a:srgbClr val="12202D"/>
+          </a:solidFill>
+          <a:ln>
+            <a:noFill/>
+          </a:ln>
+        </p:spPr>
+        <p:style>
+          <a:lnRef idx="1">
+            <a:schemeClr val="accent1"/>
+          </a:lnRef>
+          <a:fillRef idx="3">
+            <a:schemeClr val="accent1"/>
+          </a:fillRef>
+          <a:effectRef idx="2">
+            <a:schemeClr val="accent1"/>
+          </a:effectRef>
+          <a:fontRef idx="minor">
+            <a:schemeClr val="lt1"/>
+          </a:fontRef>
+        </p:style>
+        <p:txBody>
+          <a:bodyPr rtlCol="0" anchor="ctr"/>
+          <a:lstStyle/>
+          <a:p>
+            <a:pPr algn="ctr"/>
+          </a:p>
+        </p:txBody>
+      </p:sp>
+      <p:sp>
+        <p:nvSpPr>
+          <p:cNvPr id="8" name="Rounded Rectangle 7"/>
+          <p:cNvSpPr/>
+          <p:nvPr/>
+        </p:nvSpPr>
+        <p:spPr>
+          <a:xfrm>
+            <a:off x="777240" y="2240280"/>
+            <a:ext cx="1691640" cy="1463040"/>
+          </a:xfrm>
+          <a:prstGeom prst="roundRect">
+            <a:avLst/>
+          </a:prstGeom>
+          <a:solidFill>
+            <a:srgbClr val="F7F3EE"/>
+          </a:solidFill>
+          <a:ln w="15240">
+            <a:solidFill>
+              <a:srgbClr val="D6CCC1"/>
+            </a:solidFill>
+          </a:ln>
+        </p:spPr>
+        <p:style>
+          <a:lnRef idx="1">
+            <a:schemeClr val="accent1"/>
+          </a:lnRef>
+          <a:fillRef idx="3">
+            <a:schemeClr val="accent1"/>
+          </a:fillRef>
+          <a:effectRef idx="2">
+            <a:schemeClr val="accent1"/>
+          </a:effectRef>
+          <a:fontRef idx="minor">
+            <a:schemeClr val="lt1"/>
+          </a:fontRef>
+        </p:style>
+        <p:txBody>
+          <a:bodyPr rtlCol="0" anchor="ctr"/>
+          <a:lstStyle/>
+          <a:p>
+            <a:pPr algn="ctr"/>
+          </a:p>
+        </p:txBody>
+      </p:sp>
+      <p:sp>
+        <p:nvSpPr>
+          <p:cNvPr id="9" name="Rounded Rectangle 8"/>
+          <p:cNvSpPr/>
+          <p:nvPr/>
+        </p:nvSpPr>
+        <p:spPr>
+          <a:xfrm>
+            <a:off x="978408" y="2404872"/>
+            <a:ext cx="438912" cy="310896"/>
+          </a:xfrm>
+          <a:prstGeom prst="roundRect">
+            <a:avLst/>
+          </a:prstGeom>
+          <a:solidFill>
+            <a:srgbClr val="54B9D6"/>
+          </a:solidFill>
+          <a:ln>
+            <a:noFill/>
+          </a:ln>
+        </p:spPr>
+        <p:style>
+          <a:lnRef idx="1">
+            <a:schemeClr val="accent1"/>
+          </a:lnRef>
+          <a:fillRef idx="3">
+            <a:schemeClr val="accent1"/>
+          </a:fillRef>
+          <a:effectRef idx="2">
+            <a:schemeClr val="accent1"/>
+          </a:effectRef>
+          <a:fontRef idx="minor">
+            <a:schemeClr val="lt1"/>
+          </a:fontRef>
+        </p:style>
+        <p:txBody>
+          <a:bodyPr rtlCol="0" anchor="ctr" wrap="none"/>
+          <a:lstStyle/>
+          <a:p>
+            <a:pPr algn="ctr"/>
+            <a:r>
+              <a:rPr sz="900" b="1">
+                <a:solidFill>
+                  <a:srgbClr val="F4F0EB"/>
+                </a:solidFill>
+                <a:latin typeface="Aptos"/>
+              </a:rPr>
+              <a:t>1</a:t>
+            </a:r>
+          </a:p>
+        </p:txBody>
+      </p:sp>
+      <p:sp>
+        <p:nvSpPr>
+          <p:cNvPr id="10" name="TextBox 9"/>
+          <p:cNvSpPr txBox="1"/>
+          <p:nvPr/>
+        </p:nvSpPr>
+        <p:spPr>
+          <a:xfrm>
+            <a:off x="978408" y="2770632"/>
+            <a:ext cx="1289304" cy="731520"/>
+          </a:xfrm>
+          <a:prstGeom prst="rect">
+            <a:avLst/>
+          </a:prstGeom>
+          <a:noFill/>
+        </p:spPr>
+        <p:txBody>
+          <a:bodyPr wrap="square" anchor="t">
+            <a:spAutoFit/>
+          </a:bodyPr>
+          <a:lstStyle/>
+          <a:p>
+            <a:pPr>
+              <a:spcAft>
+                <a:spcPts val="300"/>
+              </a:spcAft>
+            </a:pPr>
+            <a:r>
+              <a:rPr sz="1500" b="1">
+                <a:solidFill>
+                  <a:srgbClr val="19212A"/>
+                </a:solidFill>
+                <a:latin typeface="Aptos Display"/>
+              </a:rPr>
+              <a:t>One app</a:t>
+            </a:r>
+          </a:p>
+          <a:p>
+            <a:r>
+              <a:rPr sz="1100" b="0">
+                <a:solidFill>
+                  <a:srgbClr val="57606D"/>
+                </a:solidFill>
+                <a:latin typeface="Aptos"/>
+              </a:rPr>
+              <a:t>Stay on `flight_project` and keep the first story narrow.</a:t>
+            </a:r>
+          </a:p>
+        </p:txBody>
+      </p:sp>
+      <p:sp>
+        <p:nvSpPr>
+          <p:cNvPr id="11" name="Rounded Rectangle 10"/>
+          <p:cNvSpPr/>
+          <p:nvPr/>
+        </p:nvSpPr>
+        <p:spPr>
+          <a:xfrm>
+            <a:off x="2734056" y="2313432"/>
+            <a:ext cx="1691640" cy="1463040"/>
+          </a:xfrm>
+          <a:prstGeom prst="roundRect">
+            <a:avLst/>
+          </a:prstGeom>
+          <a:solidFill>
+            <a:srgbClr val="12202D"/>
+          </a:solidFill>
+          <a:ln>
+            <a:noFill/>
+          </a:ln>
+        </p:spPr>
+        <p:style>
+          <a:lnRef idx="1">
+            <a:schemeClr val="accent1"/>
+          </a:lnRef>
+          <a:fillRef idx="3">
+            <a:schemeClr val="accent1"/>
+          </a:fillRef>
+          <a:effectRef idx="2">
+            <a:schemeClr val="accent1"/>
+          </a:effectRef>
+          <a:fontRef idx="minor">
+            <a:schemeClr val="lt1"/>
+          </a:fontRef>
+        </p:style>
+        <p:txBody>
+          <a:bodyPr rtlCol="0" anchor="ctr"/>
+          <a:lstStyle/>
+          <a:p>
+            <a:pPr algn="ctr"/>
+          </a:p>
+        </p:txBody>
+      </p:sp>
+      <p:sp>
+        <p:nvSpPr>
+          <p:cNvPr id="12" name="Rounded Rectangle 11"/>
+          <p:cNvSpPr/>
+          <p:nvPr/>
+        </p:nvSpPr>
+        <p:spPr>
+          <a:xfrm>
+            <a:off x="2670048" y="2240280"/>
+            <a:ext cx="1691640" cy="1463040"/>
+          </a:xfrm>
+          <a:prstGeom prst="roundRect">
+            <a:avLst/>
+          </a:prstGeom>
+          <a:solidFill>
+            <a:srgbClr val="F7F3EE"/>
+          </a:solidFill>
+          <a:ln w="15240">
+            <a:solidFill>
+              <a:srgbClr val="D6CCC1"/>
+            </a:solidFill>
+          </a:ln>
+        </p:spPr>
+        <p:style>
+          <a:lnRef idx="1">
+            <a:schemeClr val="accent1"/>
+          </a:lnRef>
+          <a:fillRef idx="3">
+            <a:schemeClr val="accent1"/>
+          </a:fillRef>
+          <a:effectRef idx="2">
+            <a:schemeClr val="accent1"/>
+          </a:effectRef>
+          <a:fontRef idx="minor">
+            <a:schemeClr val="lt1"/>
+          </a:fontRef>
+        </p:style>
+        <p:txBody>
+          <a:bodyPr rtlCol="0" anchor="ctr"/>
+          <a:lstStyle/>
+          <a:p>
+            <a:pPr algn="ctr"/>
+          </a:p>
+        </p:txBody>
+      </p:sp>
+      <p:sp>
+        <p:nvSpPr>
+          <p:cNvPr id="13" name="Rounded Rectangle 12"/>
+          <p:cNvSpPr/>
+          <p:nvPr/>
+        </p:nvSpPr>
+        <p:spPr>
+          <a:xfrm>
+            <a:off x="2871216" y="2404872"/>
+            <a:ext cx="438912" cy="310896"/>
+          </a:xfrm>
+          <a:prstGeom prst="roundRect">
+            <a:avLst/>
+          </a:prstGeom>
+          <a:solidFill>
+            <a:srgbClr val="54B9D6"/>
+          </a:solidFill>
+          <a:ln>
+            <a:noFill/>
+          </a:ln>
+        </p:spPr>
+        <p:style>
+          <a:lnRef idx="1">
+            <a:schemeClr val="accent1"/>
+          </a:lnRef>
+          <a:fillRef idx="3">
+            <a:schemeClr val="accent1"/>
+          </a:fillRef>
+          <a:effectRef idx="2">
+            <a:schemeClr val="accent1"/>
+          </a:effectRef>
+          <a:fontRef idx="minor">
+            <a:schemeClr val="lt1"/>
+          </a:fontRef>
+        </p:style>
+        <p:txBody>
+          <a:bodyPr rtlCol="0" anchor="ctr" wrap="none"/>
+          <a:lstStyle/>
+          <a:p>
+            <a:pPr algn="ctr"/>
+            <a:r>
+              <a:rPr sz="900" b="1">
+                <a:solidFill>
+                  <a:srgbClr val="F4F0EB"/>
+                </a:solidFill>
+                <a:latin typeface="Aptos"/>
+              </a:rPr>
+              <a:t>2</a:t>
+            </a:r>
+          </a:p>
+        </p:txBody>
+      </p:sp>
+      <p:sp>
+        <p:nvSpPr>
+          <p:cNvPr id="14" name="TextBox 13"/>
+          <p:cNvSpPr txBox="1"/>
+          <p:nvPr/>
+        </p:nvSpPr>
+        <p:spPr>
+          <a:xfrm>
+            <a:off x="2871216" y="2770632"/>
+            <a:ext cx="1289304" cy="731520"/>
+          </a:xfrm>
+          <a:prstGeom prst="rect">
+            <a:avLst/>
+          </a:prstGeom>
+          <a:noFill/>
+        </p:spPr>
+        <p:txBody>
+          <a:bodyPr wrap="square" anchor="t">
+            <a:spAutoFit/>
+          </a:bodyPr>
+          <a:lstStyle/>
+          <a:p>
+            <a:pPr>
+              <a:spcAft>
+                <a:spcPts val="300"/>
+              </a:spcAft>
+            </a:pPr>
+            <a:r>
+              <a:rPr sz="1500" b="1">
+                <a:solidFill>
+                  <a:srgbClr val="19212A"/>
+                </a:solidFill>
+                <a:latin typeface="Aptos Display"/>
+              </a:rPr>
+              <a:t>One path</a:t>
+            </a:r>
+          </a:p>
+          <a:p>
+            <a:r>
+              <a:rPr sz="1100" b="0">
+                <a:solidFill>
+                  <a:srgbClr val="57606D"/>
+                </a:solidFill>
+                <a:latin typeface="Aptos"/>
+              </a:rPr>
+              <a:t>Use PROJECT, then ORCHESTRATE, without side-shell glue.</a:t>
+            </a:r>
+          </a:p>
+        </p:txBody>
+      </p:sp>
+      <p:sp>
+        <p:nvSpPr>
+          <p:cNvPr id="15" name="Rounded Rectangle 14"/>
+          <p:cNvSpPr/>
+          <p:nvPr/>
+        </p:nvSpPr>
+        <p:spPr>
+          <a:xfrm>
+            <a:off x="4626864" y="2313432"/>
+            <a:ext cx="1691640" cy="1463040"/>
+          </a:xfrm>
+          <a:prstGeom prst="roundRect">
+            <a:avLst/>
+          </a:prstGeom>
+          <a:solidFill>
+            <a:srgbClr val="12202D"/>
+          </a:solidFill>
+          <a:ln>
+            <a:noFill/>
+          </a:ln>
+        </p:spPr>
+        <p:style>
+          <a:lnRef idx="1">
+            <a:schemeClr val="accent1"/>
+          </a:lnRef>
+          <a:fillRef idx="3">
+            <a:schemeClr val="accent1"/>
+          </a:fillRef>
+          <a:effectRef idx="2">
+            <a:schemeClr val="accent1"/>
+          </a:effectRef>
+          <a:fontRef idx="minor">
+            <a:schemeClr val="lt1"/>
+          </a:fontRef>
+        </p:style>
+        <p:txBody>
+          <a:bodyPr rtlCol="0" anchor="ctr"/>
+          <a:lstStyle/>
+          <a:p>
+            <a:pPr algn="ctr"/>
+          </a:p>
+        </p:txBody>
+      </p:sp>
+      <p:sp>
+        <p:nvSpPr>
+          <p:cNvPr id="16" name="Rounded Rectangle 15"/>
+          <p:cNvSpPr/>
+          <p:nvPr/>
+        </p:nvSpPr>
+        <p:spPr>
+          <a:xfrm>
+            <a:off x="4562856" y="2240280"/>
+            <a:ext cx="1691640" cy="1463040"/>
+          </a:xfrm>
+          <a:prstGeom prst="roundRect">
+            <a:avLst/>
+          </a:prstGeom>
+          <a:solidFill>
+            <a:srgbClr val="F7F3EE"/>
+          </a:solidFill>
+          <a:ln w="15240">
+            <a:solidFill>
+              <a:srgbClr val="D6CCC1"/>
+            </a:solidFill>
+          </a:ln>
+        </p:spPr>
+        <p:style>
+          <a:lnRef idx="1">
+            <a:schemeClr val="accent1"/>
+          </a:lnRef>
+          <a:fillRef idx="3">
+            <a:schemeClr val="accent1"/>
+          </a:fillRef>
+          <a:effectRef idx="2">
+            <a:schemeClr val="accent1"/>
+          </a:effectRef>
+          <a:fontRef idx="minor">
+            <a:schemeClr val="lt1"/>
+          </a:fontRef>
+        </p:style>
+        <p:txBody>
+          <a:bodyPr rtlCol="0" anchor="ctr"/>
+          <a:lstStyle/>
+          <a:p>
+            <a:pPr algn="ctr"/>
+          </a:p>
+        </p:txBody>
+      </p:sp>
+      <p:sp>
+        <p:nvSpPr>
+          <p:cNvPr id="17" name="Rounded Rectangle 16"/>
+          <p:cNvSpPr/>
+          <p:nvPr/>
+        </p:nvSpPr>
+        <p:spPr>
+          <a:xfrm>
+            <a:off x="4764024" y="2404872"/>
+            <a:ext cx="438912" cy="310896"/>
+          </a:xfrm>
+          <a:prstGeom prst="roundRect">
+            <a:avLst/>
+          </a:prstGeom>
+          <a:solidFill>
+            <a:srgbClr val="54B9D6"/>
+          </a:solidFill>
+          <a:ln>
+            <a:noFill/>
+          </a:ln>
+        </p:spPr>
+        <p:style>
+          <a:lnRef idx="1">
+            <a:schemeClr val="accent1"/>
+          </a:lnRef>
+          <a:fillRef idx="3">
+            <a:schemeClr val="accent1"/>
+          </a:fillRef>
+          <a:effectRef idx="2">
+            <a:schemeClr val="accent1"/>
+          </a:effectRef>
+          <a:fontRef idx="minor">
+            <a:schemeClr val="lt1"/>
+          </a:fontRef>
+        </p:style>
+        <p:txBody>
+          <a:bodyPr rtlCol="0" anchor="ctr" wrap="none"/>
+          <a:lstStyle/>
+          <a:p>
+            <a:pPr algn="ctr"/>
+            <a:r>
+              <a:rPr sz="900" b="1">
+                <a:solidFill>
+                  <a:srgbClr val="F4F0EB"/>
+                </a:solidFill>
+                <a:latin typeface="Aptos"/>
+              </a:rPr>
+              <a:t>3</a:t>
+            </a:r>
+          </a:p>
+        </p:txBody>
+      </p:sp>
+      <p:sp>
+        <p:nvSpPr>
+          <p:cNvPr id="18" name="TextBox 17"/>
+          <p:cNvSpPr txBox="1"/>
+          <p:nvPr/>
+        </p:nvSpPr>
+        <p:spPr>
+          <a:xfrm>
+            <a:off x="4764024" y="2770632"/>
+            <a:ext cx="1289304" cy="731520"/>
+          </a:xfrm>
+          <a:prstGeom prst="rect">
+            <a:avLst/>
+          </a:prstGeom>
+          <a:noFill/>
+        </p:spPr>
+        <p:txBody>
+          <a:bodyPr wrap="square" anchor="t">
+            <a:spAutoFit/>
+          </a:bodyPr>
+          <a:lstStyle/>
+          <a:p>
+            <a:pPr>
+              <a:spcAft>
+                <a:spcPts val="300"/>
+              </a:spcAft>
+            </a:pPr>
+            <a:r>
+              <a:rPr sz="1500" b="1">
+                <a:solidFill>
+                  <a:srgbClr val="19212A"/>
+                </a:solidFill>
+                <a:latin typeface="Aptos Display"/>
+              </a:rPr>
+              <a:t>One result</a:t>
+            </a:r>
+          </a:p>
+          <a:p>
+            <a:r>
+              <a:rPr sz="1100" b="0">
+                <a:solidFill>
+                  <a:srgbClr val="57606D"/>
+                </a:solidFill>
+                <a:latin typeface="Aptos"/>
+              </a:rPr>
+              <a:t>End on visible evidence in ANALYSIS rather than raw logs.</a:t>
+            </a:r>
+          </a:p>
+        </p:txBody>
+      </p:sp>
+      <p:sp>
+        <p:nvSpPr>
+          <p:cNvPr id="19" name="Rounded Rectangle 18"/>
+          <p:cNvSpPr/>
+          <p:nvPr/>
+        </p:nvSpPr>
+        <p:spPr>
+          <a:xfrm>
+            <a:off x="777240" y="4069080"/>
+            <a:ext cx="5440680" cy="786384"/>
+          </a:xfrm>
+          <a:prstGeom prst="roundRect">
+            <a:avLst/>
+          </a:prstGeom>
+          <a:solidFill>
+            <a:srgbClr val="1C2D3D"/>
+          </a:solidFill>
+          <a:ln w="15240">
+            <a:noFill/>
+          </a:ln>
+        </p:spPr>
+        <p:style>
+          <a:lnRef idx="1">
+            <a:schemeClr val="accent1"/>
+          </a:lnRef>
+          <a:fillRef idx="3">
+            <a:schemeClr val="accent1"/>
+          </a:fillRef>
+          <a:effectRef idx="2">
+            <a:schemeClr val="accent1"/>
+          </a:effectRef>
+          <a:fontRef idx="minor">
+            <a:schemeClr val="lt1"/>
+          </a:fontRef>
+        </p:style>
+        <p:txBody>
+          <a:bodyPr rtlCol="0" anchor="ctr"/>
+          <a:lstStyle/>
+          <a:p>
+            <a:pPr algn="ctr"/>
+          </a:p>
+        </p:txBody>
+      </p:sp>
+      <p:sp>
+        <p:nvSpPr>
+          <p:cNvPr id="20" name="TextBox 19"/>
+          <p:cNvSpPr txBox="1"/>
+          <p:nvPr/>
+        </p:nvSpPr>
+        <p:spPr>
+          <a:xfrm>
+            <a:off x="996696" y="4233672"/>
+            <a:ext cx="5001768" cy="566928"/>
           </a:xfrm>
           <a:prstGeom prst="rect">
             <a:avLst/>
@@ -3214,48 +3960,608 @@
           </a:bodyPr>
           <a:lstStyle/>
           <a:p>
-            <a:pPr>
-              <a:spcAft>
-                <a:spcPts val="800"/>
-              </a:spcAft>
-              <a:defRPr sz="2200">
+            <a:r>
+              <a:rPr sz="1200" b="0">
                 <a:solidFill>
-                  <a:srgbClr val="212427"/>
+                  <a:srgbClr val="F4F0EB"/>
                 </a:solidFill>
-              </a:defRPr>
-            </a:pPr>
-            <a:r>
+                <a:latin typeface="Aptos"/>
+              </a:rPr>
               <a:t>Goal: prove the safest AGILAB path once before branching into notebooks, clusters, or packaged installs.</a:t>
             </a:r>
           </a:p>
-          <a:p>
-            <a:pPr>
-              <a:spcAft>
-                <a:spcPts val="800"/>
-              </a:spcAft>
-              <a:defRPr sz="2200">
+        </p:txBody>
+      </p:sp>
+      <p:sp>
+        <p:nvSpPr>
+          <p:cNvPr id="21" name="Rounded Rectangle 20"/>
+          <p:cNvSpPr/>
+          <p:nvPr/>
+        </p:nvSpPr>
+        <p:spPr>
+          <a:xfrm>
+            <a:off x="6967728" y="1078992"/>
+            <a:ext cx="4572000" cy="2423160"/>
+          </a:xfrm>
+          <a:prstGeom prst="roundRect">
+            <a:avLst/>
+          </a:prstGeom>
+          <a:solidFill>
+            <a:srgbClr val="12202D"/>
+          </a:solidFill>
+          <a:ln>
+            <a:noFill/>
+          </a:ln>
+        </p:spPr>
+        <p:style>
+          <a:lnRef idx="1">
+            <a:schemeClr val="accent1"/>
+          </a:lnRef>
+          <a:fillRef idx="3">
+            <a:schemeClr val="accent1"/>
+          </a:fillRef>
+          <a:effectRef idx="2">
+            <a:schemeClr val="accent1"/>
+          </a:effectRef>
+          <a:fontRef idx="minor">
+            <a:schemeClr val="lt1"/>
+          </a:fontRef>
+        </p:style>
+        <p:txBody>
+          <a:bodyPr rtlCol="0" anchor="ctr"/>
+          <a:lstStyle/>
+          <a:p>
+            <a:pPr algn="ctr"/>
+          </a:p>
+        </p:txBody>
+      </p:sp>
+      <p:sp>
+        <p:nvSpPr>
+          <p:cNvPr id="22" name="Rounded Rectangle 21"/>
+          <p:cNvSpPr/>
+          <p:nvPr/>
+        </p:nvSpPr>
+        <p:spPr>
+          <a:xfrm>
+            <a:off x="6903720" y="1005840"/>
+            <a:ext cx="4572000" cy="2423160"/>
+          </a:xfrm>
+          <a:prstGeom prst="roundRect">
+            <a:avLst/>
+          </a:prstGeom>
+          <a:solidFill>
+            <a:srgbClr val="F7F3EE"/>
+          </a:solidFill>
+          <a:ln w="15240">
+            <a:solidFill>
+              <a:srgbClr val="D6CCC1"/>
+            </a:solidFill>
+          </a:ln>
+        </p:spPr>
+        <p:style>
+          <a:lnRef idx="1">
+            <a:schemeClr val="accent1"/>
+          </a:lnRef>
+          <a:fillRef idx="3">
+            <a:schemeClr val="accent1"/>
+          </a:fillRef>
+          <a:effectRef idx="2">
+            <a:schemeClr val="accent1"/>
+          </a:effectRef>
+          <a:fontRef idx="minor">
+            <a:schemeClr val="lt1"/>
+          </a:fontRef>
+        </p:style>
+        <p:txBody>
+          <a:bodyPr rtlCol="0" anchor="ctr"/>
+          <a:lstStyle/>
+          <a:p>
+            <a:pPr algn="ctr"/>
+          </a:p>
+        </p:txBody>
+      </p:sp>
+      <p:pic>
+        <p:nvPicPr>
+          <p:cNvPr id="23" name="Picture 22" descr="image.png"/>
+          <p:cNvPicPr>
+            <a:picLocks noChangeAspect="1"/>
+          </p:cNvPicPr>
+          <p:nvPr/>
+        </p:nvPicPr>
+        <p:blipFill>
+          <a:blip r:embed="rId2"/>
+          <a:stretch>
+            <a:fillRect/>
+          </a:stretch>
+        </p:blipFill>
+        <p:spPr>
+          <a:xfrm>
+            <a:off x="7013448" y="1115568"/>
+            <a:ext cx="4352544" cy="2203704"/>
+          </a:xfrm>
+          <a:prstGeom prst="rect">
+            <a:avLst/>
+          </a:prstGeom>
+        </p:spPr>
+      </p:pic>
+      <p:sp>
+        <p:nvSpPr>
+          <p:cNvPr id="24" name="Rounded Rectangle 23"/>
+          <p:cNvSpPr/>
+          <p:nvPr/>
+        </p:nvSpPr>
+        <p:spPr>
+          <a:xfrm>
+            <a:off x="7086600" y="859536"/>
+            <a:ext cx="1097280" cy="310896"/>
+          </a:xfrm>
+          <a:prstGeom prst="roundRect">
+            <a:avLst/>
+          </a:prstGeom>
+          <a:solidFill>
+            <a:srgbClr val="E86E3A"/>
+          </a:solidFill>
+          <a:ln>
+            <a:noFill/>
+          </a:ln>
+        </p:spPr>
+        <p:style>
+          <a:lnRef idx="1">
+            <a:schemeClr val="accent1"/>
+          </a:lnRef>
+          <a:fillRef idx="3">
+            <a:schemeClr val="accent1"/>
+          </a:fillRef>
+          <a:effectRef idx="2">
+            <a:schemeClr val="accent1"/>
+          </a:effectRef>
+          <a:fontRef idx="minor">
+            <a:schemeClr val="lt1"/>
+          </a:fontRef>
+        </p:style>
+        <p:txBody>
+          <a:bodyPr rtlCol="0" anchor="ctr" wrap="none"/>
+          <a:lstStyle/>
+          <a:p>
+            <a:pPr algn="ctr"/>
+            <a:r>
+              <a:rPr sz="900" b="1">
                 <a:solidFill>
-                  <a:srgbClr val="212427"/>
+                  <a:srgbClr val="F4F0EB"/>
                 </a:solidFill>
-              </a:defRPr>
-            </a:pPr>
-            <a:r>
-              <a:t>Scope: PROJECT -&gt; ORCHESTRATE -&gt; ANALYSIS on `flight_project`.</a:t>
-            </a:r>
-          </a:p>
-          <a:p>
-            <a:pPr>
-              <a:spcAft>
-                <a:spcPts val="800"/>
-              </a:spcAft>
-              <a:defRPr sz="2200">
+                <a:latin typeface="Aptos"/>
+              </a:rPr>
+              <a:t>PROJECT</a:t>
+            </a:r>
+          </a:p>
+        </p:txBody>
+      </p:sp>
+      <p:sp>
+        <p:nvSpPr>
+          <p:cNvPr id="25" name="TextBox 24"/>
+          <p:cNvSpPr txBox="1"/>
+          <p:nvPr/>
+        </p:nvSpPr>
+        <p:spPr>
+          <a:xfrm>
+            <a:off x="7068312" y="3044952"/>
+            <a:ext cx="4242816" cy="201168"/>
+          </a:xfrm>
+          <a:prstGeom prst="rect">
+            <a:avLst/>
+          </a:prstGeom>
+          <a:noFill/>
+        </p:spPr>
+        <p:txBody>
+          <a:bodyPr wrap="none">
+            <a:spAutoFit/>
+          </a:bodyPr>
+          <a:lstStyle/>
+          <a:p>
+            <a:r>
+              <a:rPr sz="1000" b="1">
                 <a:solidFill>
-                  <a:srgbClr val="212427"/>
+                  <a:srgbClr val="F4F0EB"/>
                 </a:solidFill>
-              </a:defRPr>
-            </a:pPr>
-            <a:r>
-              <a:t>Keep the message narrow: one app, one local path, one visible result.</a:t>
+                <a:latin typeface="Aptos"/>
+              </a:rPr>
+              <a:t>Select the built-in app and keep its context visible.</a:t>
+            </a:r>
+          </a:p>
+        </p:txBody>
+      </p:sp>
+      <p:sp>
+        <p:nvSpPr>
+          <p:cNvPr id="26" name="Rounded Rectangle 25"/>
+          <p:cNvSpPr/>
+          <p:nvPr/>
+        </p:nvSpPr>
+        <p:spPr>
+          <a:xfrm>
+            <a:off x="6601968" y="2724912"/>
+            <a:ext cx="4480560" cy="2423160"/>
+          </a:xfrm>
+          <a:prstGeom prst="roundRect">
+            <a:avLst/>
+          </a:prstGeom>
+          <a:solidFill>
+            <a:srgbClr val="12202D"/>
+          </a:solidFill>
+          <a:ln>
+            <a:noFill/>
+          </a:ln>
+        </p:spPr>
+        <p:style>
+          <a:lnRef idx="1">
+            <a:schemeClr val="accent1"/>
+          </a:lnRef>
+          <a:fillRef idx="3">
+            <a:schemeClr val="accent1"/>
+          </a:fillRef>
+          <a:effectRef idx="2">
+            <a:schemeClr val="accent1"/>
+          </a:effectRef>
+          <a:fontRef idx="minor">
+            <a:schemeClr val="lt1"/>
+          </a:fontRef>
+        </p:style>
+        <p:txBody>
+          <a:bodyPr rtlCol="0" anchor="ctr"/>
+          <a:lstStyle/>
+          <a:p>
+            <a:pPr algn="ctr"/>
+          </a:p>
+        </p:txBody>
+      </p:sp>
+      <p:sp>
+        <p:nvSpPr>
+          <p:cNvPr id="27" name="Rounded Rectangle 26"/>
+          <p:cNvSpPr/>
+          <p:nvPr/>
+        </p:nvSpPr>
+        <p:spPr>
+          <a:xfrm>
+            <a:off x="6537960" y="2651760"/>
+            <a:ext cx="4480560" cy="2423160"/>
+          </a:xfrm>
+          <a:prstGeom prst="roundRect">
+            <a:avLst/>
+          </a:prstGeom>
+          <a:solidFill>
+            <a:srgbClr val="F7F3EE"/>
+          </a:solidFill>
+          <a:ln w="15240">
+            <a:solidFill>
+              <a:srgbClr val="D6CCC1"/>
+            </a:solidFill>
+          </a:ln>
+        </p:spPr>
+        <p:style>
+          <a:lnRef idx="1">
+            <a:schemeClr val="accent1"/>
+          </a:lnRef>
+          <a:fillRef idx="3">
+            <a:schemeClr val="accent1"/>
+          </a:fillRef>
+          <a:effectRef idx="2">
+            <a:schemeClr val="accent1"/>
+          </a:effectRef>
+          <a:fontRef idx="minor">
+            <a:schemeClr val="lt1"/>
+          </a:fontRef>
+        </p:style>
+        <p:txBody>
+          <a:bodyPr rtlCol="0" anchor="ctr"/>
+          <a:lstStyle/>
+          <a:p>
+            <a:pPr algn="ctr"/>
+          </a:p>
+        </p:txBody>
+      </p:sp>
+      <p:pic>
+        <p:nvPicPr>
+          <p:cNvPr id="28" name="Picture 27" descr="image.png"/>
+          <p:cNvPicPr>
+            <a:picLocks noChangeAspect="1"/>
+          </p:cNvPicPr>
+          <p:nvPr/>
+        </p:nvPicPr>
+        <p:blipFill>
+          <a:blip r:embed="rId3"/>
+          <a:stretch>
+            <a:fillRect/>
+          </a:stretch>
+        </p:blipFill>
+        <p:spPr>
+          <a:xfrm>
+            <a:off x="6647688" y="2761488"/>
+            <a:ext cx="4261104" cy="2203704"/>
+          </a:xfrm>
+          <a:prstGeom prst="rect">
+            <a:avLst/>
+          </a:prstGeom>
+        </p:spPr>
+      </p:pic>
+      <p:sp>
+        <p:nvSpPr>
+          <p:cNvPr id="29" name="Rounded Rectangle 28"/>
+          <p:cNvSpPr/>
+          <p:nvPr/>
+        </p:nvSpPr>
+        <p:spPr>
+          <a:xfrm>
+            <a:off x="6720840" y="2505456"/>
+            <a:ext cx="1143000" cy="310896"/>
+          </a:xfrm>
+          <a:prstGeom prst="roundRect">
+            <a:avLst/>
+          </a:prstGeom>
+          <a:solidFill>
+            <a:srgbClr val="54B9D6"/>
+          </a:solidFill>
+          <a:ln>
+            <a:noFill/>
+          </a:ln>
+        </p:spPr>
+        <p:style>
+          <a:lnRef idx="1">
+            <a:schemeClr val="accent1"/>
+          </a:lnRef>
+          <a:fillRef idx="3">
+            <a:schemeClr val="accent1"/>
+          </a:fillRef>
+          <a:effectRef idx="2">
+            <a:schemeClr val="accent1"/>
+          </a:effectRef>
+          <a:fontRef idx="minor">
+            <a:schemeClr val="lt1"/>
+          </a:fontRef>
+        </p:style>
+        <p:txBody>
+          <a:bodyPr rtlCol="0" anchor="ctr" wrap="none"/>
+          <a:lstStyle/>
+          <a:p>
+            <a:pPr algn="ctr"/>
+            <a:r>
+              <a:rPr sz="900" b="1">
+                <a:solidFill>
+                  <a:srgbClr val="F4F0EB"/>
+                </a:solidFill>
+                <a:latin typeface="Aptos"/>
+              </a:rPr>
+              <a:t>ORCHESTRATE</a:t>
+            </a:r>
+          </a:p>
+        </p:txBody>
+      </p:sp>
+      <p:sp>
+        <p:nvSpPr>
+          <p:cNvPr id="30" name="TextBox 29"/>
+          <p:cNvSpPr txBox="1"/>
+          <p:nvPr/>
+        </p:nvSpPr>
+        <p:spPr>
+          <a:xfrm>
+            <a:off x="6702552" y="4690872"/>
+            <a:ext cx="4151376" cy="201168"/>
+          </a:xfrm>
+          <a:prstGeom prst="rect">
+            <a:avLst/>
+          </a:prstGeom>
+          <a:noFill/>
+        </p:spPr>
+        <p:txBody>
+          <a:bodyPr wrap="none">
+            <a:spAutoFit/>
+          </a:bodyPr>
+          <a:lstStyle/>
+          <a:p>
+            <a:r>
+              <a:rPr sz="1000" b="1">
+                <a:solidFill>
+                  <a:srgbClr val="F4F0EB"/>
+                </a:solidFill>
+                <a:latin typeface="Aptos"/>
+              </a:rPr>
+              <a:t>Run the local proof through one controlled path.</a:t>
+            </a:r>
+          </a:p>
+        </p:txBody>
+      </p:sp>
+      <p:sp>
+        <p:nvSpPr>
+          <p:cNvPr id="31" name="Rounded Rectangle 30"/>
+          <p:cNvSpPr/>
+          <p:nvPr/>
+        </p:nvSpPr>
+        <p:spPr>
+          <a:xfrm>
+            <a:off x="7516368" y="3959352"/>
+            <a:ext cx="3840480" cy="1965960"/>
+          </a:xfrm>
+          <a:prstGeom prst="roundRect">
+            <a:avLst/>
+          </a:prstGeom>
+          <a:solidFill>
+            <a:srgbClr val="12202D"/>
+          </a:solidFill>
+          <a:ln>
+            <a:noFill/>
+          </a:ln>
+        </p:spPr>
+        <p:style>
+          <a:lnRef idx="1">
+            <a:schemeClr val="accent1"/>
+          </a:lnRef>
+          <a:fillRef idx="3">
+            <a:schemeClr val="accent1"/>
+          </a:fillRef>
+          <a:effectRef idx="2">
+            <a:schemeClr val="accent1"/>
+          </a:effectRef>
+          <a:fontRef idx="minor">
+            <a:schemeClr val="lt1"/>
+          </a:fontRef>
+        </p:style>
+        <p:txBody>
+          <a:bodyPr rtlCol="0" anchor="ctr"/>
+          <a:lstStyle/>
+          <a:p>
+            <a:pPr algn="ctr"/>
+          </a:p>
+        </p:txBody>
+      </p:sp>
+      <p:sp>
+        <p:nvSpPr>
+          <p:cNvPr id="32" name="Rounded Rectangle 31"/>
+          <p:cNvSpPr/>
+          <p:nvPr/>
+        </p:nvSpPr>
+        <p:spPr>
+          <a:xfrm>
+            <a:off x="7452360" y="3886200"/>
+            <a:ext cx="3840480" cy="1965960"/>
+          </a:xfrm>
+          <a:prstGeom prst="roundRect">
+            <a:avLst/>
+          </a:prstGeom>
+          <a:solidFill>
+            <a:srgbClr val="F7F3EE"/>
+          </a:solidFill>
+          <a:ln w="15240">
+            <a:solidFill>
+              <a:srgbClr val="D6CCC1"/>
+            </a:solidFill>
+          </a:ln>
+        </p:spPr>
+        <p:style>
+          <a:lnRef idx="1">
+            <a:schemeClr val="accent1"/>
+          </a:lnRef>
+          <a:fillRef idx="3">
+            <a:schemeClr val="accent1"/>
+          </a:fillRef>
+          <a:effectRef idx="2">
+            <a:schemeClr val="accent1"/>
+          </a:effectRef>
+          <a:fontRef idx="minor">
+            <a:schemeClr val="lt1"/>
+          </a:fontRef>
+        </p:style>
+        <p:txBody>
+          <a:bodyPr rtlCol="0" anchor="ctr"/>
+          <a:lstStyle/>
+          <a:p>
+            <a:pPr algn="ctr"/>
+          </a:p>
+        </p:txBody>
+      </p:sp>
+      <p:pic>
+        <p:nvPicPr>
+          <p:cNvPr id="33" name="Picture 32" descr="image.png"/>
+          <p:cNvPicPr>
+            <a:picLocks noChangeAspect="1"/>
+          </p:cNvPicPr>
+          <p:nvPr/>
+        </p:nvPicPr>
+        <p:blipFill>
+          <a:blip r:embed="rId4"/>
+          <a:stretch>
+            <a:fillRect/>
+          </a:stretch>
+        </p:blipFill>
+        <p:spPr>
+          <a:xfrm>
+            <a:off x="7562088" y="3995928"/>
+            <a:ext cx="3621024" cy="1746504"/>
+          </a:xfrm>
+          <a:prstGeom prst="rect">
+            <a:avLst/>
+          </a:prstGeom>
+        </p:spPr>
+      </p:pic>
+      <p:sp>
+        <p:nvSpPr>
+          <p:cNvPr id="34" name="Rounded Rectangle 33"/>
+          <p:cNvSpPr/>
+          <p:nvPr/>
+        </p:nvSpPr>
+        <p:spPr>
+          <a:xfrm>
+            <a:off x="7635240" y="3739896"/>
+            <a:ext cx="1097280" cy="310896"/>
+          </a:xfrm>
+          <a:prstGeom prst="roundRect">
+            <a:avLst/>
+          </a:prstGeom>
+          <a:solidFill>
+            <a:srgbClr val="F5BF5B"/>
+          </a:solidFill>
+          <a:ln>
+            <a:noFill/>
+          </a:ln>
+        </p:spPr>
+        <p:style>
+          <a:lnRef idx="1">
+            <a:schemeClr val="accent1"/>
+          </a:lnRef>
+          <a:fillRef idx="3">
+            <a:schemeClr val="accent1"/>
+          </a:fillRef>
+          <a:effectRef idx="2">
+            <a:schemeClr val="accent1"/>
+          </a:effectRef>
+          <a:fontRef idx="minor">
+            <a:schemeClr val="lt1"/>
+          </a:fontRef>
+        </p:style>
+        <p:txBody>
+          <a:bodyPr rtlCol="0" anchor="ctr" wrap="none"/>
+          <a:lstStyle/>
+          <a:p>
+            <a:pPr algn="ctr"/>
+            <a:r>
+              <a:rPr sz="900" b="1">
+                <a:solidFill>
+                  <a:srgbClr val="F4F0EB"/>
+                </a:solidFill>
+                <a:latin typeface="Aptos"/>
+              </a:rPr>
+              <a:t>ANALYSIS</a:t>
+            </a:r>
+          </a:p>
+        </p:txBody>
+      </p:sp>
+      <p:sp>
+        <p:nvSpPr>
+          <p:cNvPr id="35" name="TextBox 34"/>
+          <p:cNvSpPr txBox="1"/>
+          <p:nvPr/>
+        </p:nvSpPr>
+        <p:spPr>
+          <a:xfrm>
+            <a:off x="7616952" y="5468112"/>
+            <a:ext cx="3511296" cy="201168"/>
+          </a:xfrm>
+          <a:prstGeom prst="rect">
+            <a:avLst/>
+          </a:prstGeom>
+          <a:noFill/>
+        </p:spPr>
+        <p:txBody>
+          <a:bodyPr wrap="none">
+            <a:spAutoFit/>
+          </a:bodyPr>
+          <a:lstStyle/>
+          <a:p>
+            <a:r>
+              <a:rPr sz="1000" b="1">
+                <a:solidFill>
+                  <a:srgbClr val="F4F0EB"/>
+                </a:solidFill>
+                <a:latin typeface="Aptos"/>
+              </a:rPr>
+              <a:t>Visible result, not infrastructure noise.</a:t>
             </a:r>
           </a:p>
         </p:txBody>
@@ -3274,7 +4580,7 @@
     <p:bg>
       <p:bgPr>
         <a:solidFill>
-          <a:srgbClr val="F7F3EB"/>
+          <a:srgbClr val="0B131D"/>
         </a:solidFill>
         <a:effectLst/>
       </p:bgPr>
@@ -3288,14 +4594,143 @@
       <p:grpSpPr/>
       <p:sp>
         <p:nvSpPr>
-          <p:cNvPr id="2" name="TextBox 1"/>
+          <p:cNvPr id="2" name="Rectangle 1"/>
+          <p:cNvSpPr/>
+          <p:nvPr/>
+        </p:nvSpPr>
+        <p:spPr>
+          <a:xfrm>
+            <a:off x="0" y="0"/>
+            <a:ext cx="12191695" cy="146304"/>
+          </a:xfrm>
+          <a:prstGeom prst="rect">
+            <a:avLst/>
+          </a:prstGeom>
+          <a:solidFill>
+            <a:srgbClr val="E86E3A"/>
+          </a:solidFill>
+          <a:ln>
+            <a:noFill/>
+          </a:ln>
+        </p:spPr>
+        <p:style>
+          <a:lnRef idx="1">
+            <a:schemeClr val="accent1"/>
+          </a:lnRef>
+          <a:fillRef idx="3">
+            <a:schemeClr val="accent1"/>
+          </a:fillRef>
+          <a:effectRef idx="2">
+            <a:schemeClr val="accent1"/>
+          </a:effectRef>
+          <a:fontRef idx="minor">
+            <a:schemeClr val="lt1"/>
+          </a:fontRef>
+        </p:style>
+        <p:txBody>
+          <a:bodyPr rtlCol="0" anchor="ctr"/>
+          <a:lstStyle/>
+          <a:p>
+            <a:pPr algn="ctr"/>
+          </a:p>
+        </p:txBody>
+      </p:sp>
+      <p:sp>
+        <p:nvSpPr>
+          <p:cNvPr id="3" name="Oval 2"/>
+          <p:cNvSpPr/>
+          <p:nvPr/>
+        </p:nvSpPr>
+        <p:spPr>
+          <a:xfrm>
+            <a:off x="10607040" y="-731520"/>
+            <a:ext cx="2560320" cy="2560320"/>
+          </a:xfrm>
+          <a:prstGeom prst="ellipse">
+            <a:avLst/>
+          </a:prstGeom>
+          <a:solidFill>
+            <a:srgbClr val="12202D"/>
+          </a:solidFill>
+          <a:ln>
+            <a:noFill/>
+          </a:ln>
+        </p:spPr>
+        <p:style>
+          <a:lnRef idx="1">
+            <a:schemeClr val="accent1"/>
+          </a:lnRef>
+          <a:fillRef idx="3">
+            <a:schemeClr val="accent1"/>
+          </a:fillRef>
+          <a:effectRef idx="2">
+            <a:schemeClr val="accent1"/>
+          </a:effectRef>
+          <a:fontRef idx="minor">
+            <a:schemeClr val="lt1"/>
+          </a:fontRef>
+        </p:style>
+        <p:txBody>
+          <a:bodyPr rtlCol="0" anchor="ctr"/>
+          <a:lstStyle/>
+          <a:p>
+            <a:pPr algn="ctr"/>
+          </a:p>
+        </p:txBody>
+      </p:sp>
+      <p:sp>
+        <p:nvSpPr>
+          <p:cNvPr id="4" name="Oval 3"/>
+          <p:cNvSpPr/>
+          <p:nvPr/>
+        </p:nvSpPr>
+        <p:spPr>
+          <a:xfrm>
+            <a:off x="9966960" y="5120640"/>
+            <a:ext cx="2103120" cy="2103120"/>
+          </a:xfrm>
+          <a:prstGeom prst="ellipse">
+            <a:avLst/>
+          </a:prstGeom>
+          <a:solidFill>
+            <a:srgbClr val="1C2D3D"/>
+          </a:solidFill>
+          <a:ln>
+            <a:noFill/>
+          </a:ln>
+        </p:spPr>
+        <p:style>
+          <a:lnRef idx="1">
+            <a:schemeClr val="accent1"/>
+          </a:lnRef>
+          <a:fillRef idx="3">
+            <a:schemeClr val="accent1"/>
+          </a:fillRef>
+          <a:effectRef idx="2">
+            <a:schemeClr val="accent1"/>
+          </a:effectRef>
+          <a:fontRef idx="minor">
+            <a:schemeClr val="lt1"/>
+          </a:fontRef>
+        </p:style>
+        <p:txBody>
+          <a:bodyPr rtlCol="0" anchor="ctr"/>
+          <a:lstStyle/>
+          <a:p>
+            <a:pPr algn="ctr"/>
+          </a:p>
+        </p:txBody>
+      </p:sp>
+      <p:sp>
+        <p:nvSpPr>
+          <p:cNvPr id="5" name="TextBox 4"/>
           <p:cNvSpPr txBox="1"/>
           <p:nvPr/>
         </p:nvSpPr>
         <p:spPr>
           <a:xfrm>
-            <a:off x="640080" y="502920"/>
-            <a:ext cx="10972800" cy="1005840"/>
+            <a:off x="777240" y="658368"/>
+            <a:ext cx="2286000" cy="228600"/>
           </a:xfrm>
           <a:prstGeom prst="rect">
             <a:avLst/>
@@ -3308,35 +4743,715 @@
           </a:bodyPr>
           <a:lstStyle/>
           <a:p>
-            <a:r>
-              <a:rPr sz="2800" b="1">
+            <a:pPr algn="l">
+              <a:spcBef>
+                <a:spcPts val="0"/>
+              </a:spcBef>
+              <a:spcAft>
+                <a:spcPts val="0"/>
+              </a:spcAft>
+            </a:pPr>
+            <a:r>
+              <a:rPr sz="1000" b="1">
                 <a:solidFill>
-                  <a:srgbClr val="2D5C7A"/>
+                  <a:srgbClr val="54B9D6"/>
                 </a:solidFill>
+                <a:latin typeface="Aptos"/>
+              </a:rPr>
+              <a:t>STORY LOGIC</a:t>
+            </a:r>
+          </a:p>
+        </p:txBody>
+      </p:sp>
+      <p:sp>
+        <p:nvSpPr>
+          <p:cNvPr id="6" name="TextBox 5"/>
+          <p:cNvSpPr txBox="1"/>
+          <p:nvPr/>
+        </p:nvSpPr>
+        <p:spPr>
+          <a:xfrm>
+            <a:off x="777240" y="868680"/>
+            <a:ext cx="4754880" cy="1371600"/>
+          </a:xfrm>
+          <a:prstGeom prst="rect">
+            <a:avLst/>
+          </a:prstGeom>
+          <a:noFill/>
+        </p:spPr>
+        <p:txBody>
+          <a:bodyPr wrap="square" anchor="t">
+            <a:spAutoFit/>
+          </a:bodyPr>
+          <a:lstStyle/>
+          <a:p>
+            <a:pPr algn="l">
+              <a:spcAft>
+                <a:spcPts val="300"/>
+              </a:spcAft>
+            </a:pPr>
+            <a:r>
+              <a:rPr sz="2600" b="1">
+                <a:solidFill>
+                  <a:srgbClr val="F4F0EB"/>
+                </a:solidFill>
+                <a:latin typeface="Aptos Display"/>
               </a:rPr>
               <a:t>Why This Path</a:t>
             </a:r>
           </a:p>
           <a:p>
-            <a:pPr>
+            <a:pPr algn="l">
               <a:spcBef>
-                <a:spcPts val="400"/>
+                <a:spcPts val="200"/>
               </a:spcBef>
             </a:pPr>
             <a:r>
-              <a:rPr sz="1400">
+              <a:rPr sz="1300" b="0">
                 <a:solidFill>
-                  <a:srgbClr val="5B6268"/>
+                  <a:srgbClr val="ABB7C4"/>
                 </a:solidFill>
+                <a:latin typeface="Aptos"/>
               </a:rPr>
-              <a:t>The first proof is deliberately smaller than the full tour</a:t>
-            </a:r>
+              <a:t>The first proof is deliberately smaller than the full tour.</a:t>
+            </a:r>
+          </a:p>
+        </p:txBody>
+      </p:sp>
+      <p:sp>
+        <p:nvSpPr>
+          <p:cNvPr id="7" name="Rounded Rectangle 6"/>
+          <p:cNvSpPr/>
+          <p:nvPr/>
+        </p:nvSpPr>
+        <p:spPr>
+          <a:xfrm>
+            <a:off x="841248" y="1993392"/>
+            <a:ext cx="3794760" cy="1005840"/>
+          </a:xfrm>
+          <a:prstGeom prst="roundRect">
+            <a:avLst/>
+          </a:prstGeom>
+          <a:solidFill>
+            <a:srgbClr val="12202D"/>
+          </a:solidFill>
+          <a:ln>
+            <a:noFill/>
+          </a:ln>
+        </p:spPr>
+        <p:style>
+          <a:lnRef idx="1">
+            <a:schemeClr val="accent1"/>
+          </a:lnRef>
+          <a:fillRef idx="3">
+            <a:schemeClr val="accent1"/>
+          </a:fillRef>
+          <a:effectRef idx="2">
+            <a:schemeClr val="accent1"/>
+          </a:effectRef>
+          <a:fontRef idx="minor">
+            <a:schemeClr val="lt1"/>
+          </a:fontRef>
+        </p:style>
+        <p:txBody>
+          <a:bodyPr rtlCol="0" anchor="ctr"/>
+          <a:lstStyle/>
+          <a:p>
+            <a:pPr algn="ctr"/>
+          </a:p>
+        </p:txBody>
+      </p:sp>
+      <p:sp>
+        <p:nvSpPr>
+          <p:cNvPr id="8" name="Rounded Rectangle 7"/>
+          <p:cNvSpPr/>
+          <p:nvPr/>
+        </p:nvSpPr>
+        <p:spPr>
+          <a:xfrm>
+            <a:off x="777240" y="1920240"/>
+            <a:ext cx="3794760" cy="1005840"/>
+          </a:xfrm>
+          <a:prstGeom prst="roundRect">
+            <a:avLst/>
+          </a:prstGeom>
+          <a:solidFill>
+            <a:srgbClr val="F7F3EE"/>
+          </a:solidFill>
+          <a:ln w="15240">
+            <a:solidFill>
+              <a:srgbClr val="D6CCC1"/>
+            </a:solidFill>
+          </a:ln>
+        </p:spPr>
+        <p:style>
+          <a:lnRef idx="1">
+            <a:schemeClr val="accent1"/>
+          </a:lnRef>
+          <a:fillRef idx="3">
+            <a:schemeClr val="accent1"/>
+          </a:fillRef>
+          <a:effectRef idx="2">
+            <a:schemeClr val="accent1"/>
+          </a:effectRef>
+          <a:fontRef idx="minor">
+            <a:schemeClr val="lt1"/>
+          </a:fontRef>
+        </p:style>
+        <p:txBody>
+          <a:bodyPr rtlCol="0" anchor="ctr"/>
+          <a:lstStyle/>
+          <a:p>
+            <a:pPr algn="ctr"/>
+          </a:p>
+        </p:txBody>
+      </p:sp>
+      <p:sp>
+        <p:nvSpPr>
+          <p:cNvPr id="9" name="Rectangle 8"/>
+          <p:cNvSpPr/>
+          <p:nvPr/>
+        </p:nvSpPr>
+        <p:spPr>
+          <a:xfrm>
+            <a:off x="777240" y="1920240"/>
+            <a:ext cx="118872" cy="1005840"/>
+          </a:xfrm>
+          <a:prstGeom prst="rect">
+            <a:avLst/>
+          </a:prstGeom>
+          <a:solidFill>
+            <a:srgbClr val="E86E3A"/>
+          </a:solidFill>
+          <a:ln>
+            <a:noFill/>
+          </a:ln>
+        </p:spPr>
+        <p:style>
+          <a:lnRef idx="1">
+            <a:schemeClr val="accent1"/>
+          </a:lnRef>
+          <a:fillRef idx="3">
+            <a:schemeClr val="accent1"/>
+          </a:fillRef>
+          <a:effectRef idx="2">
+            <a:schemeClr val="accent1"/>
+          </a:effectRef>
+          <a:fontRef idx="minor">
+            <a:schemeClr val="lt1"/>
+          </a:fontRef>
+        </p:style>
+        <p:txBody>
+          <a:bodyPr rtlCol="0" anchor="ctr"/>
+          <a:lstStyle/>
+          <a:p>
+            <a:pPr algn="ctr"/>
+          </a:p>
+        </p:txBody>
+      </p:sp>
+      <p:sp>
+        <p:nvSpPr>
+          <p:cNvPr id="10" name="TextBox 9"/>
+          <p:cNvSpPr txBox="1"/>
+          <p:nvPr/>
+        </p:nvSpPr>
+        <p:spPr>
+          <a:xfrm>
+            <a:off x="1033272" y="2103120"/>
+            <a:ext cx="3337560" cy="731520"/>
+          </a:xfrm>
+          <a:prstGeom prst="rect">
+            <a:avLst/>
+          </a:prstGeom>
+          <a:noFill/>
+        </p:spPr>
+        <p:txBody>
+          <a:bodyPr wrap="square">
+            <a:spAutoFit/>
+          </a:bodyPr>
+          <a:lstStyle/>
+          <a:p>
+            <a:pPr>
+              <a:spcAft>
+                <a:spcPts val="200"/>
+              </a:spcAft>
+            </a:pPr>
+            <a:r>
+              <a:rPr sz="1400" b="1">
+                <a:solidFill>
+                  <a:srgbClr val="19212A"/>
+                </a:solidFill>
+                <a:latin typeface="Aptos Display"/>
+              </a:rPr>
+              <a:t>Visible app context</a:t>
+            </a:r>
+          </a:p>
+          <a:p>
+            <a:r>
+              <a:rPr sz="1100" b="0">
+                <a:solidFill>
+                  <a:srgbClr val="57606D"/>
+                </a:solidFill>
+                <a:latin typeface="Aptos"/>
+              </a:rPr>
+              <a:t>PROJECT is not just a launcher. It keeps the selected app legible while you run it.</a:t>
+            </a:r>
+          </a:p>
+        </p:txBody>
+      </p:sp>
+      <p:sp>
+        <p:nvSpPr>
+          <p:cNvPr id="11" name="Rounded Rectangle 10"/>
+          <p:cNvSpPr/>
+          <p:nvPr/>
+        </p:nvSpPr>
+        <p:spPr>
+          <a:xfrm>
+            <a:off x="841248" y="3163824"/>
+            <a:ext cx="3794760" cy="1005840"/>
+          </a:xfrm>
+          <a:prstGeom prst="roundRect">
+            <a:avLst/>
+          </a:prstGeom>
+          <a:solidFill>
+            <a:srgbClr val="12202D"/>
+          </a:solidFill>
+          <a:ln>
+            <a:noFill/>
+          </a:ln>
+        </p:spPr>
+        <p:style>
+          <a:lnRef idx="1">
+            <a:schemeClr val="accent1"/>
+          </a:lnRef>
+          <a:fillRef idx="3">
+            <a:schemeClr val="accent1"/>
+          </a:fillRef>
+          <a:effectRef idx="2">
+            <a:schemeClr val="accent1"/>
+          </a:effectRef>
+          <a:fontRef idx="minor">
+            <a:schemeClr val="lt1"/>
+          </a:fontRef>
+        </p:style>
+        <p:txBody>
+          <a:bodyPr rtlCol="0" anchor="ctr"/>
+          <a:lstStyle/>
+          <a:p>
+            <a:pPr algn="ctr"/>
+          </a:p>
+        </p:txBody>
+      </p:sp>
+      <p:sp>
+        <p:nvSpPr>
+          <p:cNvPr id="12" name="Rounded Rectangle 11"/>
+          <p:cNvSpPr/>
+          <p:nvPr/>
+        </p:nvSpPr>
+        <p:spPr>
+          <a:xfrm>
+            <a:off x="777240" y="3090672"/>
+            <a:ext cx="3794760" cy="1005840"/>
+          </a:xfrm>
+          <a:prstGeom prst="roundRect">
+            <a:avLst/>
+          </a:prstGeom>
+          <a:solidFill>
+            <a:srgbClr val="F7F3EE"/>
+          </a:solidFill>
+          <a:ln w="15240">
+            <a:solidFill>
+              <a:srgbClr val="D6CCC1"/>
+            </a:solidFill>
+          </a:ln>
+        </p:spPr>
+        <p:style>
+          <a:lnRef idx="1">
+            <a:schemeClr val="accent1"/>
+          </a:lnRef>
+          <a:fillRef idx="3">
+            <a:schemeClr val="accent1"/>
+          </a:fillRef>
+          <a:effectRef idx="2">
+            <a:schemeClr val="accent1"/>
+          </a:effectRef>
+          <a:fontRef idx="minor">
+            <a:schemeClr val="lt1"/>
+          </a:fontRef>
+        </p:style>
+        <p:txBody>
+          <a:bodyPr rtlCol="0" anchor="ctr"/>
+          <a:lstStyle/>
+          <a:p>
+            <a:pPr algn="ctr"/>
+          </a:p>
+        </p:txBody>
+      </p:sp>
+      <p:sp>
+        <p:nvSpPr>
+          <p:cNvPr id="13" name="Rectangle 12"/>
+          <p:cNvSpPr/>
+          <p:nvPr/>
+        </p:nvSpPr>
+        <p:spPr>
+          <a:xfrm>
+            <a:off x="777240" y="3090672"/>
+            <a:ext cx="118872" cy="1005840"/>
+          </a:xfrm>
+          <a:prstGeom prst="rect">
+            <a:avLst/>
+          </a:prstGeom>
+          <a:solidFill>
+            <a:srgbClr val="54B9D6"/>
+          </a:solidFill>
+          <a:ln>
+            <a:noFill/>
+          </a:ln>
+        </p:spPr>
+        <p:style>
+          <a:lnRef idx="1">
+            <a:schemeClr val="accent1"/>
+          </a:lnRef>
+          <a:fillRef idx="3">
+            <a:schemeClr val="accent1"/>
+          </a:fillRef>
+          <a:effectRef idx="2">
+            <a:schemeClr val="accent1"/>
+          </a:effectRef>
+          <a:fontRef idx="minor">
+            <a:schemeClr val="lt1"/>
+          </a:fontRef>
+        </p:style>
+        <p:txBody>
+          <a:bodyPr rtlCol="0" anchor="ctr"/>
+          <a:lstStyle/>
+          <a:p>
+            <a:pPr algn="ctr"/>
+          </a:p>
+        </p:txBody>
+      </p:sp>
+      <p:sp>
+        <p:nvSpPr>
+          <p:cNvPr id="14" name="TextBox 13"/>
+          <p:cNvSpPr txBox="1"/>
+          <p:nvPr/>
+        </p:nvSpPr>
+        <p:spPr>
+          <a:xfrm>
+            <a:off x="1033272" y="3273552"/>
+            <a:ext cx="3337560" cy="731520"/>
+          </a:xfrm>
+          <a:prstGeom prst="rect">
+            <a:avLst/>
+          </a:prstGeom>
+          <a:noFill/>
+        </p:spPr>
+        <p:txBody>
+          <a:bodyPr wrap="square">
+            <a:spAutoFit/>
+          </a:bodyPr>
+          <a:lstStyle/>
+          <a:p>
+            <a:pPr>
+              <a:spcAft>
+                <a:spcPts val="200"/>
+              </a:spcAft>
+            </a:pPr>
+            <a:r>
+              <a:rPr sz="1400" b="1">
+                <a:solidFill>
+                  <a:srgbClr val="19212A"/>
+                </a:solidFill>
+                <a:latin typeface="Aptos Display"/>
+              </a:rPr>
+              <a:t>Controlled execution</a:t>
+            </a:r>
+          </a:p>
+          <a:p>
+            <a:r>
+              <a:rPr sz="1100" b="0">
+                <a:solidFill>
+                  <a:srgbClr val="57606D"/>
+                </a:solidFill>
+                <a:latin typeface="Aptos"/>
+              </a:rPr>
+              <a:t>ORCHESTRATE packages and runs the local path without asking the viewer to infer shell state.</a:t>
+            </a:r>
+          </a:p>
+        </p:txBody>
+      </p:sp>
+      <p:sp>
+        <p:nvSpPr>
+          <p:cNvPr id="15" name="Rounded Rectangle 14"/>
+          <p:cNvSpPr/>
+          <p:nvPr/>
+        </p:nvSpPr>
+        <p:spPr>
+          <a:xfrm>
+            <a:off x="841248" y="4334256"/>
+            <a:ext cx="3794760" cy="1005840"/>
+          </a:xfrm>
+          <a:prstGeom prst="roundRect">
+            <a:avLst/>
+          </a:prstGeom>
+          <a:solidFill>
+            <a:srgbClr val="12202D"/>
+          </a:solidFill>
+          <a:ln>
+            <a:noFill/>
+          </a:ln>
+        </p:spPr>
+        <p:style>
+          <a:lnRef idx="1">
+            <a:schemeClr val="accent1"/>
+          </a:lnRef>
+          <a:fillRef idx="3">
+            <a:schemeClr val="accent1"/>
+          </a:fillRef>
+          <a:effectRef idx="2">
+            <a:schemeClr val="accent1"/>
+          </a:effectRef>
+          <a:fontRef idx="minor">
+            <a:schemeClr val="lt1"/>
+          </a:fontRef>
+        </p:style>
+        <p:txBody>
+          <a:bodyPr rtlCol="0" anchor="ctr"/>
+          <a:lstStyle/>
+          <a:p>
+            <a:pPr algn="ctr"/>
+          </a:p>
+        </p:txBody>
+      </p:sp>
+      <p:sp>
+        <p:nvSpPr>
+          <p:cNvPr id="16" name="Rounded Rectangle 15"/>
+          <p:cNvSpPr/>
+          <p:nvPr/>
+        </p:nvSpPr>
+        <p:spPr>
+          <a:xfrm>
+            <a:off x="777240" y="4261104"/>
+            <a:ext cx="3794760" cy="1005840"/>
+          </a:xfrm>
+          <a:prstGeom prst="roundRect">
+            <a:avLst/>
+          </a:prstGeom>
+          <a:solidFill>
+            <a:srgbClr val="F7F3EE"/>
+          </a:solidFill>
+          <a:ln w="15240">
+            <a:solidFill>
+              <a:srgbClr val="D6CCC1"/>
+            </a:solidFill>
+          </a:ln>
+        </p:spPr>
+        <p:style>
+          <a:lnRef idx="1">
+            <a:schemeClr val="accent1"/>
+          </a:lnRef>
+          <a:fillRef idx="3">
+            <a:schemeClr val="accent1"/>
+          </a:fillRef>
+          <a:effectRef idx="2">
+            <a:schemeClr val="accent1"/>
+          </a:effectRef>
+          <a:fontRef idx="minor">
+            <a:schemeClr val="lt1"/>
+          </a:fontRef>
+        </p:style>
+        <p:txBody>
+          <a:bodyPr rtlCol="0" anchor="ctr"/>
+          <a:lstStyle/>
+          <a:p>
+            <a:pPr algn="ctr"/>
+          </a:p>
+        </p:txBody>
+      </p:sp>
+      <p:sp>
+        <p:nvSpPr>
+          <p:cNvPr id="17" name="Rectangle 16"/>
+          <p:cNvSpPr/>
+          <p:nvPr/>
+        </p:nvSpPr>
+        <p:spPr>
+          <a:xfrm>
+            <a:off x="777240" y="4261104"/>
+            <a:ext cx="118872" cy="1005840"/>
+          </a:xfrm>
+          <a:prstGeom prst="rect">
+            <a:avLst/>
+          </a:prstGeom>
+          <a:solidFill>
+            <a:srgbClr val="F5BF5B"/>
+          </a:solidFill>
+          <a:ln>
+            <a:noFill/>
+          </a:ln>
+        </p:spPr>
+        <p:style>
+          <a:lnRef idx="1">
+            <a:schemeClr val="accent1"/>
+          </a:lnRef>
+          <a:fillRef idx="3">
+            <a:schemeClr val="accent1"/>
+          </a:fillRef>
+          <a:effectRef idx="2">
+            <a:schemeClr val="accent1"/>
+          </a:effectRef>
+          <a:fontRef idx="minor">
+            <a:schemeClr val="lt1"/>
+          </a:fontRef>
+        </p:style>
+        <p:txBody>
+          <a:bodyPr rtlCol="0" anchor="ctr"/>
+          <a:lstStyle/>
+          <a:p>
+            <a:pPr algn="ctr"/>
+          </a:p>
+        </p:txBody>
+      </p:sp>
+      <p:sp>
+        <p:nvSpPr>
+          <p:cNvPr id="18" name="TextBox 17"/>
+          <p:cNvSpPr txBox="1"/>
+          <p:nvPr/>
+        </p:nvSpPr>
+        <p:spPr>
+          <a:xfrm>
+            <a:off x="1033272" y="4443984"/>
+            <a:ext cx="3337560" cy="731520"/>
+          </a:xfrm>
+          <a:prstGeom prst="rect">
+            <a:avLst/>
+          </a:prstGeom>
+          <a:noFill/>
+        </p:spPr>
+        <p:txBody>
+          <a:bodyPr wrap="square">
+            <a:spAutoFit/>
+          </a:bodyPr>
+          <a:lstStyle/>
+          <a:p>
+            <a:pPr>
+              <a:spcAft>
+                <a:spcPts val="200"/>
+              </a:spcAft>
+            </a:pPr>
+            <a:r>
+              <a:rPr sz="1400" b="1">
+                <a:solidFill>
+                  <a:srgbClr val="19212A"/>
+                </a:solidFill>
+                <a:latin typeface="Aptos Display"/>
+              </a:rPr>
+              <a:t>Readable proof</a:t>
+            </a:r>
+          </a:p>
+          <a:p>
+            <a:r>
+              <a:rPr sz="1100" b="0">
+                <a:solidFill>
+                  <a:srgbClr val="57606D"/>
+                </a:solidFill>
+                <a:latin typeface="Aptos"/>
+              </a:rPr>
+              <a:t>ANALYSIS is the payoff: a result a technical audience can parse in seconds.</a:t>
+            </a:r>
+          </a:p>
+        </p:txBody>
+      </p:sp>
+      <p:sp>
+        <p:nvSpPr>
+          <p:cNvPr id="19" name="Rounded Rectangle 18"/>
+          <p:cNvSpPr/>
+          <p:nvPr/>
+        </p:nvSpPr>
+        <p:spPr>
+          <a:xfrm>
+            <a:off x="5047488" y="1490472"/>
+            <a:ext cx="6309360" cy="4114800"/>
+          </a:xfrm>
+          <a:prstGeom prst="roundRect">
+            <a:avLst/>
+          </a:prstGeom>
+          <a:solidFill>
+            <a:srgbClr val="12202D"/>
+          </a:solidFill>
+          <a:ln>
+            <a:noFill/>
+          </a:ln>
+        </p:spPr>
+        <p:style>
+          <a:lnRef idx="1">
+            <a:schemeClr val="accent1"/>
+          </a:lnRef>
+          <a:fillRef idx="3">
+            <a:schemeClr val="accent1"/>
+          </a:fillRef>
+          <a:effectRef idx="2">
+            <a:schemeClr val="accent1"/>
+          </a:effectRef>
+          <a:fontRef idx="minor">
+            <a:schemeClr val="lt1"/>
+          </a:fontRef>
+        </p:style>
+        <p:txBody>
+          <a:bodyPr rtlCol="0" anchor="ctr"/>
+          <a:lstStyle/>
+          <a:p>
+            <a:pPr algn="ctr"/>
+          </a:p>
+        </p:txBody>
+      </p:sp>
+      <p:sp>
+        <p:nvSpPr>
+          <p:cNvPr id="20" name="Rounded Rectangle 19"/>
+          <p:cNvSpPr/>
+          <p:nvPr/>
+        </p:nvSpPr>
+        <p:spPr>
+          <a:xfrm>
+            <a:off x="4983480" y="1417320"/>
+            <a:ext cx="6309360" cy="4114800"/>
+          </a:xfrm>
+          <a:prstGeom prst="roundRect">
+            <a:avLst/>
+          </a:prstGeom>
+          <a:solidFill>
+            <a:srgbClr val="F7F3EE"/>
+          </a:solidFill>
+          <a:ln w="15240">
+            <a:solidFill>
+              <a:srgbClr val="D6CCC1"/>
+            </a:solidFill>
+          </a:ln>
+        </p:spPr>
+        <p:style>
+          <a:lnRef idx="1">
+            <a:schemeClr val="accent1"/>
+          </a:lnRef>
+          <a:fillRef idx="3">
+            <a:schemeClr val="accent1"/>
+          </a:fillRef>
+          <a:effectRef idx="2">
+            <a:schemeClr val="accent1"/>
+          </a:effectRef>
+          <a:fontRef idx="minor">
+            <a:schemeClr val="lt1"/>
+          </a:fontRef>
+        </p:style>
+        <p:txBody>
+          <a:bodyPr rtlCol="0" anchor="ctr"/>
+          <a:lstStyle/>
+          <a:p>
+            <a:pPr algn="ctr"/>
           </a:p>
         </p:txBody>
       </p:sp>
       <p:pic>
         <p:nvPicPr>
-          <p:cNvPr id="3" name="Picture 2" descr="core-pages-overview.png"/>
+          <p:cNvPr id="21" name="Picture 20" descr="image.png"/>
           <p:cNvPicPr>
             <a:picLocks noChangeAspect="1"/>
           </p:cNvPicPr>
@@ -3350,8 +5465,8 @@
         </p:blipFill>
         <p:spPr>
           <a:xfrm>
-            <a:off x="640080" y="1371600"/>
-            <a:ext cx="5669280" cy="3410712"/>
+            <a:off x="5093208" y="1527048"/>
+            <a:ext cx="6089904" cy="3895344"/>
           </a:xfrm>
           <a:prstGeom prst="rect">
             <a:avLst/>
@@ -3360,25 +5475,23 @@
       </p:pic>
       <p:sp>
         <p:nvSpPr>
-          <p:cNvPr id="4" name="Rounded Rectangle 3"/>
+          <p:cNvPr id="22" name="Rounded Rectangle 21"/>
           <p:cNvSpPr/>
           <p:nvPr/>
         </p:nvSpPr>
         <p:spPr>
           <a:xfrm>
-            <a:off x="6583680" y="1371600"/>
-            <a:ext cx="4937760" cy="3200400"/>
+            <a:off x="5166360" y="1271016"/>
+            <a:ext cx="1097280" cy="310896"/>
           </a:xfrm>
           <a:prstGeom prst="roundRect">
             <a:avLst/>
           </a:prstGeom>
           <a:solidFill>
-            <a:srgbClr val="FFFBF5"/>
-          </a:solidFill>
-          <a:ln w="19050">
-            <a:solidFill>
-              <a:srgbClr val="DCCEBF"/>
-            </a:solidFill>
+            <a:srgbClr val="54B9D6"/>
+          </a:solidFill>
+          <a:ln>
+            <a:noFill/>
           </a:ln>
         </p:spPr>
         <p:style>
@@ -3396,23 +5509,32 @@
           </a:fontRef>
         </p:style>
         <p:txBody>
-          <a:bodyPr rtlCol="0" anchor="ctr"/>
+          <a:bodyPr rtlCol="0" anchor="ctr" wrap="none"/>
           <a:lstStyle/>
           <a:p>
             <a:pPr algn="ctr"/>
-          </a:p>
-        </p:txBody>
-      </p:sp>
-      <p:sp>
-        <p:nvSpPr>
-          <p:cNvPr id="5" name="TextBox 4"/>
+            <a:r>
+              <a:rPr sz="900" b="1">
+                <a:solidFill>
+                  <a:srgbClr val="F4F0EB"/>
+                </a:solidFill>
+                <a:latin typeface="Aptos"/>
+              </a:rPr>
+              <a:t>UI FLOW</a:t>
+            </a:r>
+          </a:p>
+        </p:txBody>
+      </p:sp>
+      <p:sp>
+        <p:nvSpPr>
+          <p:cNvPr id="23" name="TextBox 22"/>
           <p:cNvSpPr txBox="1"/>
           <p:nvPr/>
         </p:nvSpPr>
         <p:spPr>
           <a:xfrm>
-            <a:off x="6858000" y="1737360"/>
-            <a:ext cx="4389120" cy="2468880"/>
+            <a:off x="5148072" y="5148072"/>
+            <a:ext cx="5980176" cy="201168"/>
           </a:xfrm>
           <a:prstGeom prst="rect">
             <a:avLst/>
@@ -3420,78 +5542,42 @@
           <a:noFill/>
         </p:spPr>
         <p:txBody>
-          <a:bodyPr wrap="square">
+          <a:bodyPr wrap="none">
             <a:spAutoFit/>
           </a:bodyPr>
           <a:lstStyle/>
           <a:p>
-            <a:pPr>
-              <a:spcAft>
-                <a:spcPts val="800"/>
-              </a:spcAft>
-              <a:defRPr sz="1800">
+            <a:r>
+              <a:rPr sz="1000" b="1">
                 <a:solidFill>
-                  <a:srgbClr val="212427"/>
+                  <a:srgbClr val="F4F0EB"/>
                 </a:solidFill>
-              </a:defRPr>
-            </a:pPr>
-            <a:r>
-              <a:t>Select the built-in app once and keep its context visible.</a:t>
-            </a:r>
-          </a:p>
-          <a:p>
-            <a:pPr>
-              <a:spcAft>
-                <a:spcPts val="800"/>
-              </a:spcAft>
-              <a:defRPr sz="1800">
-                <a:solidFill>
-                  <a:srgbClr val="212427"/>
-                </a:solidFill>
-              </a:defRPr>
-            </a:pPr>
-            <a:r>
-              <a:t>Run the local path through ORCHESTRATE without ad-hoc shell glue.</a:t>
-            </a:r>
-          </a:p>
-          <a:p>
-            <a:pPr>
-              <a:spcAft>
-                <a:spcPts val="800"/>
-              </a:spcAft>
-              <a:defRPr sz="1800">
-                <a:solidFill>
-                  <a:srgbClr val="212427"/>
-                </a:solidFill>
-              </a:defRPr>
-            </a:pPr>
-            <a:r>
-              <a:t>End on visible analysis evidence instead of raw logs.</a:t>
-            </a:r>
-          </a:p>
-        </p:txBody>
-      </p:sp>
-      <p:sp>
-        <p:nvSpPr>
-          <p:cNvPr id="6" name="Rounded Rectangle 5"/>
+                <a:latin typeface="Aptos"/>
+              </a:rPr>
+              <a:t>PROJECT → ORCHESTRATE → ANALYSIS is the newcomer-safe route through the UI.</a:t>
+            </a:r>
+          </a:p>
+        </p:txBody>
+      </p:sp>
+      <p:sp>
+        <p:nvSpPr>
+          <p:cNvPr id="24" name="Rounded Rectangle 23"/>
           <p:cNvSpPr/>
           <p:nvPr/>
         </p:nvSpPr>
         <p:spPr>
           <a:xfrm>
-            <a:off x="640080" y="4754880"/>
-            <a:ext cx="10881360" cy="1005840"/>
+            <a:off x="777240" y="5650992"/>
+            <a:ext cx="10561320" cy="786384"/>
           </a:xfrm>
           <a:prstGeom prst="roundRect">
             <a:avLst/>
           </a:prstGeom>
           <a:solidFill>
-            <a:srgbClr val="FFFBF5"/>
-          </a:solidFill>
-          <a:ln w="19050">
-            <a:solidFill>
-              <a:srgbClr val="DCCEBF"/>
-            </a:solidFill>
+            <a:srgbClr val="1C2D3D"/>
+          </a:solidFill>
+          <a:ln w="15240">
+            <a:noFill/>
           </a:ln>
         </p:spPr>
         <p:style>
@@ -3518,14 +5604,14 @@
       </p:sp>
       <p:sp>
         <p:nvSpPr>
-          <p:cNvPr id="7" name="TextBox 6"/>
+          <p:cNvPr id="25" name="TextBox 24"/>
           <p:cNvSpPr txBox="1"/>
           <p:nvPr/>
         </p:nvSpPr>
         <p:spPr>
           <a:xfrm>
-            <a:off x="914400" y="4983480"/>
-            <a:ext cx="10332720" cy="548640"/>
+            <a:off x="996696" y="5815584"/>
+            <a:ext cx="10122408" cy="566928"/>
           </a:xfrm>
           <a:prstGeom prst="rect">
             <a:avLst/>
@@ -3538,18 +5624,14 @@
           </a:bodyPr>
           <a:lstStyle/>
           <a:p>
-            <a:pPr>
-              <a:spcAft>
-                <a:spcPts val="800"/>
-              </a:spcAft>
-              <a:defRPr sz="1800">
+            <a:r>
+              <a:rPr sz="1200" b="0">
                 <a:solidFill>
-                  <a:srgbClr val="212427"/>
+                  <a:srgbClr val="F4F0EB"/>
                 </a:solidFill>
-              </a:defRPr>
-            </a:pPr>
-            <a:r>
-              <a:t>Narration: this is the newcomer-safe proof that AGILAB can take one app from selection to visible evidence.</a:t>
+                <a:latin typeface="Aptos"/>
+              </a:rPr>
+              <a:t>Narration: this is the smallest AGILAB story that still proves real workflow control and a visible result.</a:t>
             </a:r>
           </a:p>
         </p:txBody>
@@ -3568,7 +5650,7 @@
     <p:bg>
       <p:bgPr>
         <a:solidFill>
-          <a:srgbClr val="F7F3EB"/>
+          <a:srgbClr val="0B131D"/>
         </a:solidFill>
         <a:effectLst/>
       </p:bgPr>
@@ -3582,14 +5664,143 @@
       <p:grpSpPr/>
       <p:sp>
         <p:nvSpPr>
-          <p:cNvPr id="2" name="TextBox 1"/>
+          <p:cNvPr id="2" name="Rectangle 1"/>
+          <p:cNvSpPr/>
+          <p:nvPr/>
+        </p:nvSpPr>
+        <p:spPr>
+          <a:xfrm>
+            <a:off x="0" y="0"/>
+            <a:ext cx="12191695" cy="146304"/>
+          </a:xfrm>
+          <a:prstGeom prst="rect">
+            <a:avLst/>
+          </a:prstGeom>
+          <a:solidFill>
+            <a:srgbClr val="E86E3A"/>
+          </a:solidFill>
+          <a:ln>
+            <a:noFill/>
+          </a:ln>
+        </p:spPr>
+        <p:style>
+          <a:lnRef idx="1">
+            <a:schemeClr val="accent1"/>
+          </a:lnRef>
+          <a:fillRef idx="3">
+            <a:schemeClr val="accent1"/>
+          </a:fillRef>
+          <a:effectRef idx="2">
+            <a:schemeClr val="accent1"/>
+          </a:effectRef>
+          <a:fontRef idx="minor">
+            <a:schemeClr val="lt1"/>
+          </a:fontRef>
+        </p:style>
+        <p:txBody>
+          <a:bodyPr rtlCol="0" anchor="ctr"/>
+          <a:lstStyle/>
+          <a:p>
+            <a:pPr algn="ctr"/>
+          </a:p>
+        </p:txBody>
+      </p:sp>
+      <p:sp>
+        <p:nvSpPr>
+          <p:cNvPr id="3" name="Oval 2"/>
+          <p:cNvSpPr/>
+          <p:nvPr/>
+        </p:nvSpPr>
+        <p:spPr>
+          <a:xfrm>
+            <a:off x="10607040" y="-731520"/>
+            <a:ext cx="2560320" cy="2560320"/>
+          </a:xfrm>
+          <a:prstGeom prst="ellipse">
+            <a:avLst/>
+          </a:prstGeom>
+          <a:solidFill>
+            <a:srgbClr val="12202D"/>
+          </a:solidFill>
+          <a:ln>
+            <a:noFill/>
+          </a:ln>
+        </p:spPr>
+        <p:style>
+          <a:lnRef idx="1">
+            <a:schemeClr val="accent1"/>
+          </a:lnRef>
+          <a:fillRef idx="3">
+            <a:schemeClr val="accent1"/>
+          </a:fillRef>
+          <a:effectRef idx="2">
+            <a:schemeClr val="accent1"/>
+          </a:effectRef>
+          <a:fontRef idx="minor">
+            <a:schemeClr val="lt1"/>
+          </a:fontRef>
+        </p:style>
+        <p:txBody>
+          <a:bodyPr rtlCol="0" anchor="ctr"/>
+          <a:lstStyle/>
+          <a:p>
+            <a:pPr algn="ctr"/>
+          </a:p>
+        </p:txBody>
+      </p:sp>
+      <p:sp>
+        <p:nvSpPr>
+          <p:cNvPr id="4" name="Oval 3"/>
+          <p:cNvSpPr/>
+          <p:nvPr/>
+        </p:nvSpPr>
+        <p:spPr>
+          <a:xfrm>
+            <a:off x="9966960" y="5120640"/>
+            <a:ext cx="2103120" cy="2103120"/>
+          </a:xfrm>
+          <a:prstGeom prst="ellipse">
+            <a:avLst/>
+          </a:prstGeom>
+          <a:solidFill>
+            <a:srgbClr val="1C2D3D"/>
+          </a:solidFill>
+          <a:ln>
+            <a:noFill/>
+          </a:ln>
+        </p:spPr>
+        <p:style>
+          <a:lnRef idx="1">
+            <a:schemeClr val="accent1"/>
+          </a:lnRef>
+          <a:fillRef idx="3">
+            <a:schemeClr val="accent1"/>
+          </a:fillRef>
+          <a:effectRef idx="2">
+            <a:schemeClr val="accent1"/>
+          </a:effectRef>
+          <a:fontRef idx="minor">
+            <a:schemeClr val="lt1"/>
+          </a:fontRef>
+        </p:style>
+        <p:txBody>
+          <a:bodyPr rtlCol="0" anchor="ctr"/>
+          <a:lstStyle/>
+          <a:p>
+            <a:pPr algn="ctr"/>
+          </a:p>
+        </p:txBody>
+      </p:sp>
+      <p:sp>
+        <p:nvSpPr>
+          <p:cNvPr id="5" name="TextBox 4"/>
           <p:cNvSpPr txBox="1"/>
           <p:nvPr/>
         </p:nvSpPr>
         <p:spPr>
           <a:xfrm>
-            <a:off x="640080" y="502920"/>
-            <a:ext cx="10972800" cy="1005840"/>
+            <a:off x="777240" y="658368"/>
+            <a:ext cx="2286000" cy="228600"/>
           </a:xfrm>
           <a:prstGeom prst="rect">
             <a:avLst/>
@@ -3602,35 +5813,276 @@
           </a:bodyPr>
           <a:lstStyle/>
           <a:p>
-            <a:r>
-              <a:rPr sz="2800" b="1">
+            <a:pPr algn="l">
+              <a:spcBef>
+                <a:spcPts val="0"/>
+              </a:spcBef>
+              <a:spcAft>
+                <a:spcPts val="0"/>
+              </a:spcAft>
+            </a:pPr>
+            <a:r>
+              <a:rPr sz="1000" b="1">
                 <a:solidFill>
-                  <a:srgbClr val="2D5C7A"/>
+                  <a:srgbClr val="54B9D6"/>
                 </a:solidFill>
+                <a:latin typeface="Aptos"/>
+              </a:rPr>
+              <a:t>EXECUTION PATH</a:t>
+            </a:r>
+          </a:p>
+        </p:txBody>
+      </p:sp>
+      <p:sp>
+        <p:nvSpPr>
+          <p:cNvPr id="6" name="TextBox 5"/>
+          <p:cNvSpPr txBox="1"/>
+          <p:nvPr/>
+        </p:nvSpPr>
+        <p:spPr>
+          <a:xfrm>
+            <a:off x="777240" y="868680"/>
+            <a:ext cx="6400800" cy="1371600"/>
+          </a:xfrm>
+          <a:prstGeom prst="rect">
+            <a:avLst/>
+          </a:prstGeom>
+          <a:noFill/>
+        </p:spPr>
+        <p:txBody>
+          <a:bodyPr wrap="square" anchor="t">
+            <a:spAutoFit/>
+          </a:bodyPr>
+          <a:lstStyle/>
+          <a:p>
+            <a:pPr algn="l">
+              <a:spcAft>
+                <a:spcPts val="300"/>
+              </a:spcAft>
+            </a:pPr>
+            <a:r>
+              <a:rPr sz="2600" b="1">
+                <a:solidFill>
+                  <a:srgbClr val="F4F0EB"/>
+                </a:solidFill>
+                <a:latin typeface="Aptos Display"/>
               </a:rPr>
               <a:t>Select And Run</a:t>
             </a:r>
           </a:p>
           <a:p>
-            <a:pPr>
+            <a:pPr algn="l">
               <a:spcBef>
-                <a:spcPts val="400"/>
+                <a:spcPts val="200"/>
               </a:spcBef>
             </a:pPr>
             <a:r>
-              <a:rPr sz="1400">
+              <a:rPr sz="1300" b="0">
                 <a:solidFill>
-                  <a:srgbClr val="5B6268"/>
+                  <a:srgbClr val="ABB7C4"/>
                 </a:solidFill>
+                <a:latin typeface="Aptos"/>
               </a:rPr>
-              <a:t>PROJECT sets the app context; ORCHESTRATE executes the local proof</a:t>
-            </a:r>
+              <a:t>PROJECT sets the app context; ORCHESTRATE executes the local proof.</a:t>
+            </a:r>
+          </a:p>
+        </p:txBody>
+      </p:sp>
+      <p:sp>
+        <p:nvSpPr>
+          <p:cNvPr id="7" name="Rounded Rectangle 6"/>
+          <p:cNvSpPr/>
+          <p:nvPr/>
+        </p:nvSpPr>
+        <p:spPr>
+          <a:xfrm>
+            <a:off x="777240" y="1737360"/>
+            <a:ext cx="1197864" cy="310896"/>
+          </a:xfrm>
+          <a:prstGeom prst="roundRect">
+            <a:avLst/>
+          </a:prstGeom>
+          <a:solidFill>
+            <a:srgbClr val="E86E3A"/>
+          </a:solidFill>
+          <a:ln>
+            <a:noFill/>
+          </a:ln>
+        </p:spPr>
+        <p:style>
+          <a:lnRef idx="1">
+            <a:schemeClr val="accent1"/>
+          </a:lnRef>
+          <a:fillRef idx="3">
+            <a:schemeClr val="accent1"/>
+          </a:fillRef>
+          <a:effectRef idx="2">
+            <a:schemeClr val="accent1"/>
+          </a:effectRef>
+          <a:fontRef idx="minor">
+            <a:schemeClr val="lt1"/>
+          </a:fontRef>
+        </p:style>
+        <p:txBody>
+          <a:bodyPr rtlCol="0" anchor="ctr" wrap="none"/>
+          <a:lstStyle/>
+          <a:p>
+            <a:pPr algn="ctr"/>
+            <a:r>
+              <a:rPr sz="900" b="1">
+                <a:solidFill>
+                  <a:srgbClr val="F4F0EB"/>
+                </a:solidFill>
+                <a:latin typeface="Aptos"/>
+              </a:rPr>
+              <a:t>1 PROJECT</a:t>
+            </a:r>
+          </a:p>
+        </p:txBody>
+      </p:sp>
+      <p:sp>
+        <p:nvSpPr>
+          <p:cNvPr id="8" name="Rounded Rectangle 7"/>
+          <p:cNvSpPr/>
+          <p:nvPr/>
+        </p:nvSpPr>
+        <p:spPr>
+          <a:xfrm>
+            <a:off x="2084832" y="1737360"/>
+            <a:ext cx="1527048" cy="310896"/>
+          </a:xfrm>
+          <a:prstGeom prst="roundRect">
+            <a:avLst/>
+          </a:prstGeom>
+          <a:solidFill>
+            <a:srgbClr val="54B9D6"/>
+          </a:solidFill>
+          <a:ln>
+            <a:noFill/>
+          </a:ln>
+        </p:spPr>
+        <p:style>
+          <a:lnRef idx="1">
+            <a:schemeClr val="accent1"/>
+          </a:lnRef>
+          <a:fillRef idx="3">
+            <a:schemeClr val="accent1"/>
+          </a:fillRef>
+          <a:effectRef idx="2">
+            <a:schemeClr val="accent1"/>
+          </a:effectRef>
+          <a:fontRef idx="minor">
+            <a:schemeClr val="lt1"/>
+          </a:fontRef>
+        </p:style>
+        <p:txBody>
+          <a:bodyPr rtlCol="0" anchor="ctr" wrap="none"/>
+          <a:lstStyle/>
+          <a:p>
+            <a:pPr algn="ctr"/>
+            <a:r>
+              <a:rPr sz="900" b="1">
+                <a:solidFill>
+                  <a:srgbClr val="F4F0EB"/>
+                </a:solidFill>
+                <a:latin typeface="Aptos"/>
+              </a:rPr>
+              <a:t>2 ORCHESTRATE</a:t>
+            </a:r>
+          </a:p>
+        </p:txBody>
+      </p:sp>
+      <p:sp>
+        <p:nvSpPr>
+          <p:cNvPr id="9" name="Rounded Rectangle 8"/>
+          <p:cNvSpPr/>
+          <p:nvPr/>
+        </p:nvSpPr>
+        <p:spPr>
+          <a:xfrm>
+            <a:off x="841248" y="2221992"/>
+            <a:ext cx="5074920" cy="3017520"/>
+          </a:xfrm>
+          <a:prstGeom prst="roundRect">
+            <a:avLst/>
+          </a:prstGeom>
+          <a:solidFill>
+            <a:srgbClr val="12202D"/>
+          </a:solidFill>
+          <a:ln>
+            <a:noFill/>
+          </a:ln>
+        </p:spPr>
+        <p:style>
+          <a:lnRef idx="1">
+            <a:schemeClr val="accent1"/>
+          </a:lnRef>
+          <a:fillRef idx="3">
+            <a:schemeClr val="accent1"/>
+          </a:fillRef>
+          <a:effectRef idx="2">
+            <a:schemeClr val="accent1"/>
+          </a:effectRef>
+          <a:fontRef idx="minor">
+            <a:schemeClr val="lt1"/>
+          </a:fontRef>
+        </p:style>
+        <p:txBody>
+          <a:bodyPr rtlCol="0" anchor="ctr"/>
+          <a:lstStyle/>
+          <a:p>
+            <a:pPr algn="ctr"/>
+          </a:p>
+        </p:txBody>
+      </p:sp>
+      <p:sp>
+        <p:nvSpPr>
+          <p:cNvPr id="10" name="Rounded Rectangle 9"/>
+          <p:cNvSpPr/>
+          <p:nvPr/>
+        </p:nvSpPr>
+        <p:spPr>
+          <a:xfrm>
+            <a:off x="777240" y="2148840"/>
+            <a:ext cx="5074920" cy="3017520"/>
+          </a:xfrm>
+          <a:prstGeom prst="roundRect">
+            <a:avLst/>
+          </a:prstGeom>
+          <a:solidFill>
+            <a:srgbClr val="F7F3EE"/>
+          </a:solidFill>
+          <a:ln w="15240">
+            <a:solidFill>
+              <a:srgbClr val="D6CCC1"/>
+            </a:solidFill>
+          </a:ln>
+        </p:spPr>
+        <p:style>
+          <a:lnRef idx="1">
+            <a:schemeClr val="accent1"/>
+          </a:lnRef>
+          <a:fillRef idx="3">
+            <a:schemeClr val="accent1"/>
+          </a:fillRef>
+          <a:effectRef idx="2">
+            <a:schemeClr val="accent1"/>
+          </a:effectRef>
+          <a:fontRef idx="minor">
+            <a:schemeClr val="lt1"/>
+          </a:fontRef>
+        </p:style>
+        <p:txBody>
+          <a:bodyPr rtlCol="0" anchor="ctr"/>
+          <a:lstStyle/>
+          <a:p>
+            <a:pPr algn="ctr"/>
           </a:p>
         </p:txBody>
       </p:sp>
       <p:pic>
         <p:nvPicPr>
-          <p:cNvPr id="3" name="Picture 2" descr="project-page.png"/>
+          <p:cNvPr id="11" name="Picture 10" descr="image.png"/>
           <p:cNvPicPr>
             <a:picLocks noChangeAspect="1"/>
           </p:cNvPicPr>
@@ -3644,17 +6096,191 @@
         </p:blipFill>
         <p:spPr>
           <a:xfrm>
-            <a:off x="640080" y="1417320"/>
-            <a:ext cx="5257800" cy="2990088"/>
+            <a:off x="886968" y="2258568"/>
+            <a:ext cx="4855464" cy="2798064"/>
           </a:xfrm>
           <a:prstGeom prst="rect">
             <a:avLst/>
           </a:prstGeom>
         </p:spPr>
       </p:pic>
+      <p:sp>
+        <p:nvSpPr>
+          <p:cNvPr id="12" name="Rounded Rectangle 11"/>
+          <p:cNvSpPr/>
+          <p:nvPr/>
+        </p:nvSpPr>
+        <p:spPr>
+          <a:xfrm>
+            <a:off x="960120" y="2002536"/>
+            <a:ext cx="1097280" cy="310896"/>
+          </a:xfrm>
+          <a:prstGeom prst="roundRect">
+            <a:avLst/>
+          </a:prstGeom>
+          <a:solidFill>
+            <a:srgbClr val="E86E3A"/>
+          </a:solidFill>
+          <a:ln>
+            <a:noFill/>
+          </a:ln>
+        </p:spPr>
+        <p:style>
+          <a:lnRef idx="1">
+            <a:schemeClr val="accent1"/>
+          </a:lnRef>
+          <a:fillRef idx="3">
+            <a:schemeClr val="accent1"/>
+          </a:fillRef>
+          <a:effectRef idx="2">
+            <a:schemeClr val="accent1"/>
+          </a:effectRef>
+          <a:fontRef idx="minor">
+            <a:schemeClr val="lt1"/>
+          </a:fontRef>
+        </p:style>
+        <p:txBody>
+          <a:bodyPr rtlCol="0" anchor="ctr" wrap="none"/>
+          <a:lstStyle/>
+          <a:p>
+            <a:pPr algn="ctr"/>
+            <a:r>
+              <a:rPr sz="900" b="1">
+                <a:solidFill>
+                  <a:srgbClr val="F4F0EB"/>
+                </a:solidFill>
+                <a:latin typeface="Aptos"/>
+              </a:rPr>
+              <a:t>PROJECT</a:t>
+            </a:r>
+          </a:p>
+        </p:txBody>
+      </p:sp>
+      <p:sp>
+        <p:nvSpPr>
+          <p:cNvPr id="13" name="TextBox 12"/>
+          <p:cNvSpPr txBox="1"/>
+          <p:nvPr/>
+        </p:nvSpPr>
+        <p:spPr>
+          <a:xfrm>
+            <a:off x="941832" y="4782312"/>
+            <a:ext cx="4745736" cy="201168"/>
+          </a:xfrm>
+          <a:prstGeom prst="rect">
+            <a:avLst/>
+          </a:prstGeom>
+          <a:noFill/>
+        </p:spPr>
+        <p:txBody>
+          <a:bodyPr wrap="none">
+            <a:spAutoFit/>
+          </a:bodyPr>
+          <a:lstStyle/>
+          <a:p>
+            <a:r>
+              <a:rPr sz="1000" b="1">
+                <a:solidFill>
+                  <a:srgbClr val="F4F0EB"/>
+                </a:solidFill>
+                <a:latin typeface="Aptos"/>
+              </a:rPr>
+              <a:t>Choose `flight_project` and keep the scenario visible.</a:t>
+            </a:r>
+          </a:p>
+        </p:txBody>
+      </p:sp>
+      <p:sp>
+        <p:nvSpPr>
+          <p:cNvPr id="14" name="Rounded Rectangle 13"/>
+          <p:cNvSpPr/>
+          <p:nvPr/>
+        </p:nvSpPr>
+        <p:spPr>
+          <a:xfrm>
+            <a:off x="6419088" y="2221992"/>
+            <a:ext cx="5074920" cy="3017520"/>
+          </a:xfrm>
+          <a:prstGeom prst="roundRect">
+            <a:avLst/>
+          </a:prstGeom>
+          <a:solidFill>
+            <a:srgbClr val="12202D"/>
+          </a:solidFill>
+          <a:ln>
+            <a:noFill/>
+          </a:ln>
+        </p:spPr>
+        <p:style>
+          <a:lnRef idx="1">
+            <a:schemeClr val="accent1"/>
+          </a:lnRef>
+          <a:fillRef idx="3">
+            <a:schemeClr val="accent1"/>
+          </a:fillRef>
+          <a:effectRef idx="2">
+            <a:schemeClr val="accent1"/>
+          </a:effectRef>
+          <a:fontRef idx="minor">
+            <a:schemeClr val="lt1"/>
+          </a:fontRef>
+        </p:style>
+        <p:txBody>
+          <a:bodyPr rtlCol="0" anchor="ctr"/>
+          <a:lstStyle/>
+          <a:p>
+            <a:pPr algn="ctr"/>
+          </a:p>
+        </p:txBody>
+      </p:sp>
+      <p:sp>
+        <p:nvSpPr>
+          <p:cNvPr id="15" name="Rounded Rectangle 14"/>
+          <p:cNvSpPr/>
+          <p:nvPr/>
+        </p:nvSpPr>
+        <p:spPr>
+          <a:xfrm>
+            <a:off x="6355080" y="2148840"/>
+            <a:ext cx="5074920" cy="3017520"/>
+          </a:xfrm>
+          <a:prstGeom prst="roundRect">
+            <a:avLst/>
+          </a:prstGeom>
+          <a:solidFill>
+            <a:srgbClr val="F7F3EE"/>
+          </a:solidFill>
+          <a:ln w="15240">
+            <a:solidFill>
+              <a:srgbClr val="D6CCC1"/>
+            </a:solidFill>
+          </a:ln>
+        </p:spPr>
+        <p:style>
+          <a:lnRef idx="1">
+            <a:schemeClr val="accent1"/>
+          </a:lnRef>
+          <a:fillRef idx="3">
+            <a:schemeClr val="accent1"/>
+          </a:fillRef>
+          <a:effectRef idx="2">
+            <a:schemeClr val="accent1"/>
+          </a:effectRef>
+          <a:fontRef idx="minor">
+            <a:schemeClr val="lt1"/>
+          </a:fontRef>
+        </p:style>
+        <p:txBody>
+          <a:bodyPr rtlCol="0" anchor="ctr"/>
+          <a:lstStyle/>
+          <a:p>
+            <a:pPr algn="ctr"/>
+          </a:p>
+        </p:txBody>
+      </p:sp>
       <p:pic>
         <p:nvPicPr>
-          <p:cNvPr id="4" name="Picture 3" descr="orchestrate-page.png"/>
+          <p:cNvPr id="16" name="Picture 15" descr="image.png"/>
           <p:cNvPicPr>
             <a:picLocks noChangeAspect="1"/>
           </p:cNvPicPr>
@@ -3668,8 +6294,8 @@
         </p:blipFill>
         <p:spPr>
           <a:xfrm>
-            <a:off x="6263640" y="1417320"/>
-            <a:ext cx="5257800" cy="2990088"/>
+            <a:off x="6464808" y="2258568"/>
+            <a:ext cx="4855464" cy="2798064"/>
           </a:xfrm>
           <a:prstGeom prst="rect">
             <a:avLst/>
@@ -3678,25 +6304,23 @@
       </p:pic>
       <p:sp>
         <p:nvSpPr>
-          <p:cNvPr id="5" name="Rounded Rectangle 4"/>
+          <p:cNvPr id="17" name="Rounded Rectangle 16"/>
           <p:cNvSpPr/>
           <p:nvPr/>
         </p:nvSpPr>
         <p:spPr>
           <a:xfrm>
-            <a:off x="640080" y="4709160"/>
-            <a:ext cx="10881360" cy="1097280"/>
+            <a:off x="6537960" y="2002536"/>
+            <a:ext cx="1143000" cy="310896"/>
           </a:xfrm>
           <a:prstGeom prst="roundRect">
             <a:avLst/>
           </a:prstGeom>
           <a:solidFill>
-            <a:srgbClr val="FFFBF5"/>
-          </a:solidFill>
-          <a:ln w="19050">
-            <a:solidFill>
-              <a:srgbClr val="DCCEBF"/>
-            </a:solidFill>
+            <a:srgbClr val="54B9D6"/>
+          </a:solidFill>
+          <a:ln>
+            <a:noFill/>
           </a:ln>
         </p:spPr>
         <p:style>
@@ -3714,23 +6338,32 @@
           </a:fontRef>
         </p:style>
         <p:txBody>
-          <a:bodyPr rtlCol="0" anchor="ctr"/>
+          <a:bodyPr rtlCol="0" anchor="ctr" wrap="none"/>
           <a:lstStyle/>
           <a:p>
             <a:pPr algn="ctr"/>
-          </a:p>
-        </p:txBody>
-      </p:sp>
-      <p:sp>
-        <p:nvSpPr>
-          <p:cNvPr id="6" name="TextBox 5"/>
+            <a:r>
+              <a:rPr sz="900" b="1">
+                <a:solidFill>
+                  <a:srgbClr val="F4F0EB"/>
+                </a:solidFill>
+                <a:latin typeface="Aptos"/>
+              </a:rPr>
+              <a:t>ORCHESTRATE</a:t>
+            </a:r>
+          </a:p>
+        </p:txBody>
+      </p:sp>
+      <p:sp>
+        <p:nvSpPr>
+          <p:cNvPr id="18" name="TextBox 17"/>
           <p:cNvSpPr txBox="1"/>
           <p:nvPr/>
         </p:nvSpPr>
         <p:spPr>
           <a:xfrm>
-            <a:off x="914400" y="4937760"/>
-            <a:ext cx="10332720" cy="640080"/>
+            <a:off x="6519672" y="4782312"/>
+            <a:ext cx="4745736" cy="201168"/>
           </a:xfrm>
           <a:prstGeom prst="rect">
             <a:avLst/>
@@ -3738,38 +6371,137 @@
           <a:noFill/>
         </p:spPr>
         <p:txBody>
-          <a:bodyPr wrap="square">
+          <a:bodyPr wrap="none">
             <a:spAutoFit/>
           </a:bodyPr>
           <a:lstStyle/>
           <a:p>
-            <a:pPr>
+            <a:r>
+              <a:rPr sz="1000" b="1">
+                <a:solidFill>
+                  <a:srgbClr val="F4F0EB"/>
+                </a:solidFill>
+                <a:latin typeface="Aptos"/>
+              </a:rPr>
+              <a:t>INSTALL, then EXECUTE through the local path.</a:t>
+            </a:r>
+          </a:p>
+        </p:txBody>
+      </p:sp>
+      <p:sp>
+        <p:nvSpPr>
+          <p:cNvPr id="19" name="Rounded Rectangle 18"/>
+          <p:cNvSpPr/>
+          <p:nvPr/>
+        </p:nvSpPr>
+        <p:spPr>
+          <a:xfrm>
+            <a:off x="777240" y="5486400"/>
+            <a:ext cx="10652760" cy="822960"/>
+          </a:xfrm>
+          <a:prstGeom prst="roundRect">
+            <a:avLst/>
+          </a:prstGeom>
+          <a:solidFill>
+            <a:srgbClr val="F7F3EE"/>
+          </a:solidFill>
+          <a:ln w="15240">
+            <a:solidFill>
+              <a:srgbClr val="D6CCC1"/>
+            </a:solidFill>
+          </a:ln>
+        </p:spPr>
+        <p:style>
+          <a:lnRef idx="1">
+            <a:schemeClr val="accent1"/>
+          </a:lnRef>
+          <a:fillRef idx="3">
+            <a:schemeClr val="accent1"/>
+          </a:fillRef>
+          <a:effectRef idx="2">
+            <a:schemeClr val="accent1"/>
+          </a:effectRef>
+          <a:fontRef idx="minor">
+            <a:schemeClr val="lt1"/>
+          </a:fontRef>
+        </p:style>
+        <p:txBody>
+          <a:bodyPr rtlCol="0" anchor="ctr"/>
+          <a:lstStyle/>
+          <a:p>
+            <a:pPr algn="ctr"/>
+          </a:p>
+        </p:txBody>
+      </p:sp>
+      <p:sp>
+        <p:nvSpPr>
+          <p:cNvPr id="20" name="TextBox 19"/>
+          <p:cNvSpPr txBox="1"/>
+          <p:nvPr/>
+        </p:nvSpPr>
+        <p:spPr>
+          <a:xfrm>
+            <a:off x="1005840" y="5650992"/>
+            <a:ext cx="10149840" cy="457200"/>
+          </a:xfrm>
+          <a:prstGeom prst="rect">
+            <a:avLst/>
+          </a:prstGeom>
+          <a:noFill/>
+        </p:spPr>
+        <p:txBody>
+          <a:bodyPr wrap="square" anchor="t">
+            <a:spAutoFit/>
+          </a:bodyPr>
+          <a:lstStyle/>
+          <a:p>
+            <a:pPr algn="l">
               <a:spcAft>
                 <a:spcPts val="800"/>
               </a:spcAft>
-              <a:defRPr sz="1800">
+            </a:pPr>
+            <a:r>
+              <a:rPr sz="1200" b="1">
                 <a:solidFill>
-                  <a:srgbClr val="212427"/>
+                  <a:srgbClr val="E86E3A"/>
                 </a:solidFill>
-              </a:defRPr>
-            </a:pPr>
-            <a:r>
-              <a:t>Use `flight_project`: choose it in PROJECT, then INSTALL and EXECUTE in ORCHESTRATE.</a:t>
-            </a:r>
-          </a:p>
-          <a:p>
-            <a:pPr>
+                <a:latin typeface="Aptos"/>
+              </a:rPr>
+              <a:t>— </a:t>
+            </a:r>
+            <a:r>
+              <a:rPr sz="1200" b="0">
+                <a:solidFill>
+                  <a:srgbClr val="19212A"/>
+                </a:solidFill>
+                <a:latin typeface="Aptos"/>
+              </a:rPr>
+              <a:t>Use `flight_project`: the first proof is not about breadth; it is about getting one clean end-to-end run.</a:t>
+            </a:r>
+          </a:p>
+          <a:p>
+            <a:pPr algn="l">
               <a:spcAft>
                 <a:spcPts val="800"/>
               </a:spcAft>
-              <a:defRPr sz="1800">
+            </a:pPr>
+            <a:r>
+              <a:rPr sz="1200" b="1">
                 <a:solidFill>
-                  <a:srgbClr val="212427"/>
+                  <a:srgbClr val="E86E3A"/>
                 </a:solidFill>
-              </a:defRPr>
-            </a:pPr>
-            <a:r>
-              <a:t>Keep the visual story simple and operator-visible.</a:t>
+                <a:latin typeface="Aptos"/>
+              </a:rPr>
+              <a:t>— </a:t>
+            </a:r>
+            <a:r>
+              <a:rPr sz="1200" b="0">
+                <a:solidFill>
+                  <a:srgbClr val="19212A"/>
+                </a:solidFill>
+                <a:latin typeface="Aptos"/>
+              </a:rPr>
+              <a:t>Keep the visual story simple and operator-visible so the evidence reads immediately.</a:t>
             </a:r>
           </a:p>
         </p:txBody>
@@ -3788,7 +6520,7 @@
     <p:bg>
       <p:bgPr>
         <a:solidFill>
-          <a:srgbClr val="F7F3EB"/>
+          <a:srgbClr val="0B131D"/>
         </a:solidFill>
         <a:effectLst/>
       </p:bgPr>
@@ -3802,14 +6534,143 @@
       <p:grpSpPr/>
       <p:sp>
         <p:nvSpPr>
-          <p:cNvPr id="2" name="TextBox 1"/>
+          <p:cNvPr id="2" name="Rectangle 1"/>
+          <p:cNvSpPr/>
+          <p:nvPr/>
+        </p:nvSpPr>
+        <p:spPr>
+          <a:xfrm>
+            <a:off x="0" y="0"/>
+            <a:ext cx="12191695" cy="146304"/>
+          </a:xfrm>
+          <a:prstGeom prst="rect">
+            <a:avLst/>
+          </a:prstGeom>
+          <a:solidFill>
+            <a:srgbClr val="E86E3A"/>
+          </a:solidFill>
+          <a:ln>
+            <a:noFill/>
+          </a:ln>
+        </p:spPr>
+        <p:style>
+          <a:lnRef idx="1">
+            <a:schemeClr val="accent1"/>
+          </a:lnRef>
+          <a:fillRef idx="3">
+            <a:schemeClr val="accent1"/>
+          </a:fillRef>
+          <a:effectRef idx="2">
+            <a:schemeClr val="accent1"/>
+          </a:effectRef>
+          <a:fontRef idx="minor">
+            <a:schemeClr val="lt1"/>
+          </a:fontRef>
+        </p:style>
+        <p:txBody>
+          <a:bodyPr rtlCol="0" anchor="ctr"/>
+          <a:lstStyle/>
+          <a:p>
+            <a:pPr algn="ctr"/>
+          </a:p>
+        </p:txBody>
+      </p:sp>
+      <p:sp>
+        <p:nvSpPr>
+          <p:cNvPr id="3" name="Oval 2"/>
+          <p:cNvSpPr/>
+          <p:nvPr/>
+        </p:nvSpPr>
+        <p:spPr>
+          <a:xfrm>
+            <a:off x="10607040" y="-731520"/>
+            <a:ext cx="2560320" cy="2560320"/>
+          </a:xfrm>
+          <a:prstGeom prst="ellipse">
+            <a:avLst/>
+          </a:prstGeom>
+          <a:solidFill>
+            <a:srgbClr val="12202D"/>
+          </a:solidFill>
+          <a:ln>
+            <a:noFill/>
+          </a:ln>
+        </p:spPr>
+        <p:style>
+          <a:lnRef idx="1">
+            <a:schemeClr val="accent1"/>
+          </a:lnRef>
+          <a:fillRef idx="3">
+            <a:schemeClr val="accent1"/>
+          </a:fillRef>
+          <a:effectRef idx="2">
+            <a:schemeClr val="accent1"/>
+          </a:effectRef>
+          <a:fontRef idx="minor">
+            <a:schemeClr val="lt1"/>
+          </a:fontRef>
+        </p:style>
+        <p:txBody>
+          <a:bodyPr rtlCol="0" anchor="ctr"/>
+          <a:lstStyle/>
+          <a:p>
+            <a:pPr algn="ctr"/>
+          </a:p>
+        </p:txBody>
+      </p:sp>
+      <p:sp>
+        <p:nvSpPr>
+          <p:cNvPr id="4" name="Oval 3"/>
+          <p:cNvSpPr/>
+          <p:nvPr/>
+        </p:nvSpPr>
+        <p:spPr>
+          <a:xfrm>
+            <a:off x="9966960" y="5120640"/>
+            <a:ext cx="2103120" cy="2103120"/>
+          </a:xfrm>
+          <a:prstGeom prst="ellipse">
+            <a:avLst/>
+          </a:prstGeom>
+          <a:solidFill>
+            <a:srgbClr val="1C2D3D"/>
+          </a:solidFill>
+          <a:ln>
+            <a:noFill/>
+          </a:ln>
+        </p:spPr>
+        <p:style>
+          <a:lnRef idx="1">
+            <a:schemeClr val="accent1"/>
+          </a:lnRef>
+          <a:fillRef idx="3">
+            <a:schemeClr val="accent1"/>
+          </a:fillRef>
+          <a:effectRef idx="2">
+            <a:schemeClr val="accent1"/>
+          </a:effectRef>
+          <a:fontRef idx="minor">
+            <a:schemeClr val="lt1"/>
+          </a:fontRef>
+        </p:style>
+        <p:txBody>
+          <a:bodyPr rtlCol="0" anchor="ctr"/>
+          <a:lstStyle/>
+          <a:p>
+            <a:pPr algn="ctr"/>
+          </a:p>
+        </p:txBody>
+      </p:sp>
+      <p:sp>
+        <p:nvSpPr>
+          <p:cNvPr id="5" name="TextBox 4"/>
           <p:cNvSpPr txBox="1"/>
           <p:nvPr/>
         </p:nvSpPr>
         <p:spPr>
           <a:xfrm>
-            <a:off x="640080" y="502920"/>
-            <a:ext cx="10972800" cy="1005840"/>
+            <a:off x="777240" y="658368"/>
+            <a:ext cx="2286000" cy="228600"/>
           </a:xfrm>
           <a:prstGeom prst="rect">
             <a:avLst/>
@@ -3822,35 +6683,663 @@
           </a:bodyPr>
           <a:lstStyle/>
           <a:p>
-            <a:r>
-              <a:rPr sz="2800" b="1">
+            <a:pPr algn="l">
+              <a:spcBef>
+                <a:spcPts val="0"/>
+              </a:spcBef>
+              <a:spcAft>
+                <a:spcPts val="0"/>
+              </a:spcAft>
+            </a:pPr>
+            <a:r>
+              <a:rPr sz="1000" b="1">
                 <a:solidFill>
-                  <a:srgbClr val="2D5C7A"/>
+                  <a:srgbClr val="54B9D6"/>
                 </a:solidFill>
+                <a:latin typeface="Aptos"/>
+              </a:rPr>
+              <a:t>PROOF STATE</a:t>
+            </a:r>
+          </a:p>
+        </p:txBody>
+      </p:sp>
+      <p:sp>
+        <p:nvSpPr>
+          <p:cNvPr id="6" name="TextBox 5"/>
+          <p:cNvSpPr txBox="1"/>
+          <p:nvPr/>
+        </p:nvSpPr>
+        <p:spPr>
+          <a:xfrm>
+            <a:off x="777240" y="868680"/>
+            <a:ext cx="4572000" cy="1371600"/>
+          </a:xfrm>
+          <a:prstGeom prst="rect">
+            <a:avLst/>
+          </a:prstGeom>
+          <a:noFill/>
+        </p:spPr>
+        <p:txBody>
+          <a:bodyPr wrap="square" anchor="t">
+            <a:spAutoFit/>
+          </a:bodyPr>
+          <a:lstStyle/>
+          <a:p>
+            <a:pPr algn="l">
+              <a:spcAft>
+                <a:spcPts val="300"/>
+              </a:spcAft>
+            </a:pPr>
+            <a:r>
+              <a:rPr sz="2600" b="1">
+                <a:solidFill>
+                  <a:srgbClr val="F4F0EB"/>
+                </a:solidFill>
+                <a:latin typeface="Aptos Display"/>
               </a:rPr>
               <a:t>End On Evidence</a:t>
             </a:r>
           </a:p>
           <a:p>
-            <a:pPr>
+            <a:pPr algn="l">
               <a:spcBef>
-                <a:spcPts val="400"/>
+                <a:spcPts val="200"/>
               </a:spcBef>
             </a:pPr>
             <a:r>
-              <a:rPr sz="1400">
+              <a:rPr sz="1300" b="0">
                 <a:solidFill>
-                  <a:srgbClr val="5B6268"/>
+                  <a:srgbClr val="ABB7C4"/>
                 </a:solidFill>
+                <a:latin typeface="Aptos"/>
               </a:rPr>
-              <a:t>ANALYSIS is where the first proof becomes concrete</a:t>
-            </a:r>
+              <a:t>ANALYSIS is where the first proof becomes concrete.</a:t>
+            </a:r>
+          </a:p>
+        </p:txBody>
+      </p:sp>
+      <p:sp>
+        <p:nvSpPr>
+          <p:cNvPr id="7" name="Rounded Rectangle 6"/>
+          <p:cNvSpPr/>
+          <p:nvPr/>
+        </p:nvSpPr>
+        <p:spPr>
+          <a:xfrm>
+            <a:off x="841248" y="1947671"/>
+            <a:ext cx="3886200" cy="1188720"/>
+          </a:xfrm>
+          <a:prstGeom prst="roundRect">
+            <a:avLst/>
+          </a:prstGeom>
+          <a:solidFill>
+            <a:srgbClr val="12202D"/>
+          </a:solidFill>
+          <a:ln>
+            <a:noFill/>
+          </a:ln>
+        </p:spPr>
+        <p:style>
+          <a:lnRef idx="1">
+            <a:schemeClr val="accent1"/>
+          </a:lnRef>
+          <a:fillRef idx="3">
+            <a:schemeClr val="accent1"/>
+          </a:fillRef>
+          <a:effectRef idx="2">
+            <a:schemeClr val="accent1"/>
+          </a:effectRef>
+          <a:fontRef idx="minor">
+            <a:schemeClr val="lt1"/>
+          </a:fontRef>
+        </p:style>
+        <p:txBody>
+          <a:bodyPr rtlCol="0" anchor="ctr"/>
+          <a:lstStyle/>
+          <a:p>
+            <a:pPr algn="ctr"/>
+          </a:p>
+        </p:txBody>
+      </p:sp>
+      <p:sp>
+        <p:nvSpPr>
+          <p:cNvPr id="8" name="Rounded Rectangle 7"/>
+          <p:cNvSpPr/>
+          <p:nvPr/>
+        </p:nvSpPr>
+        <p:spPr>
+          <a:xfrm>
+            <a:off x="777240" y="1874519"/>
+            <a:ext cx="3886200" cy="1188720"/>
+          </a:xfrm>
+          <a:prstGeom prst="roundRect">
+            <a:avLst/>
+          </a:prstGeom>
+          <a:solidFill>
+            <a:srgbClr val="F7F3EE"/>
+          </a:solidFill>
+          <a:ln w="15240">
+            <a:solidFill>
+              <a:srgbClr val="D6CCC1"/>
+            </a:solidFill>
+          </a:ln>
+        </p:spPr>
+        <p:style>
+          <a:lnRef idx="1">
+            <a:schemeClr val="accent1"/>
+          </a:lnRef>
+          <a:fillRef idx="3">
+            <a:schemeClr val="accent1"/>
+          </a:fillRef>
+          <a:effectRef idx="2">
+            <a:schemeClr val="accent1"/>
+          </a:effectRef>
+          <a:fontRef idx="minor">
+            <a:schemeClr val="lt1"/>
+          </a:fontRef>
+        </p:style>
+        <p:txBody>
+          <a:bodyPr rtlCol="0" anchor="ctr"/>
+          <a:lstStyle/>
+          <a:p>
+            <a:pPr algn="ctr"/>
+          </a:p>
+        </p:txBody>
+      </p:sp>
+      <p:sp>
+        <p:nvSpPr>
+          <p:cNvPr id="9" name="Rectangle 8"/>
+          <p:cNvSpPr/>
+          <p:nvPr/>
+        </p:nvSpPr>
+        <p:spPr>
+          <a:xfrm>
+            <a:off x="777240" y="1874519"/>
+            <a:ext cx="118872" cy="1188720"/>
+          </a:xfrm>
+          <a:prstGeom prst="rect">
+            <a:avLst/>
+          </a:prstGeom>
+          <a:solidFill>
+            <a:srgbClr val="E86E3A"/>
+          </a:solidFill>
+          <a:ln>
+            <a:noFill/>
+          </a:ln>
+        </p:spPr>
+        <p:style>
+          <a:lnRef idx="1">
+            <a:schemeClr val="accent1"/>
+          </a:lnRef>
+          <a:fillRef idx="3">
+            <a:schemeClr val="accent1"/>
+          </a:fillRef>
+          <a:effectRef idx="2">
+            <a:schemeClr val="accent1"/>
+          </a:effectRef>
+          <a:fontRef idx="minor">
+            <a:schemeClr val="lt1"/>
+          </a:fontRef>
+        </p:style>
+        <p:txBody>
+          <a:bodyPr rtlCol="0" anchor="ctr"/>
+          <a:lstStyle/>
+          <a:p>
+            <a:pPr algn="ctr"/>
+          </a:p>
+        </p:txBody>
+      </p:sp>
+      <p:sp>
+        <p:nvSpPr>
+          <p:cNvPr id="10" name="TextBox 9"/>
+          <p:cNvSpPr txBox="1"/>
+          <p:nvPr/>
+        </p:nvSpPr>
+        <p:spPr>
+          <a:xfrm>
+            <a:off x="1033272" y="2057399"/>
+            <a:ext cx="3429000" cy="914400"/>
+          </a:xfrm>
+          <a:prstGeom prst="rect">
+            <a:avLst/>
+          </a:prstGeom>
+          <a:noFill/>
+        </p:spPr>
+        <p:txBody>
+          <a:bodyPr wrap="square">
+            <a:spAutoFit/>
+          </a:bodyPr>
+          <a:lstStyle/>
+          <a:p>
+            <a:pPr>
+              <a:spcAft>
+                <a:spcPts val="200"/>
+              </a:spcAft>
+            </a:pPr>
+            <a:r>
+              <a:rPr sz="1400" b="1">
+                <a:solidFill>
+                  <a:srgbClr val="19212A"/>
+                </a:solidFill>
+                <a:latin typeface="Aptos Display"/>
+              </a:rPr>
+              <a:t>Proof condition</a:t>
+            </a:r>
+          </a:p>
+          <a:p>
+            <a:r>
+              <a:rPr sz="1100" b="0">
+                <a:solidFill>
+                  <a:srgbClr val="57606D"/>
+                </a:solidFill>
+                <a:latin typeface="Aptos"/>
+              </a:rPr>
+              <a:t>Fresh output under `~/log/execute/flight/` plus a readable ANALYSIS result means the newcomer hurdle is cleared.</a:t>
+            </a:r>
+          </a:p>
+        </p:txBody>
+      </p:sp>
+      <p:sp>
+        <p:nvSpPr>
+          <p:cNvPr id="11" name="Rounded Rectangle 10"/>
+          <p:cNvSpPr/>
+          <p:nvPr/>
+        </p:nvSpPr>
+        <p:spPr>
+          <a:xfrm>
+            <a:off x="841248" y="3346704"/>
+            <a:ext cx="3886200" cy="1188720"/>
+          </a:xfrm>
+          <a:prstGeom prst="roundRect">
+            <a:avLst/>
+          </a:prstGeom>
+          <a:solidFill>
+            <a:srgbClr val="12202D"/>
+          </a:solidFill>
+          <a:ln>
+            <a:noFill/>
+          </a:ln>
+        </p:spPr>
+        <p:style>
+          <a:lnRef idx="1">
+            <a:schemeClr val="accent1"/>
+          </a:lnRef>
+          <a:fillRef idx="3">
+            <a:schemeClr val="accent1"/>
+          </a:fillRef>
+          <a:effectRef idx="2">
+            <a:schemeClr val="accent1"/>
+          </a:effectRef>
+          <a:fontRef idx="minor">
+            <a:schemeClr val="lt1"/>
+          </a:fontRef>
+        </p:style>
+        <p:txBody>
+          <a:bodyPr rtlCol="0" anchor="ctr"/>
+          <a:lstStyle/>
+          <a:p>
+            <a:pPr algn="ctr"/>
+          </a:p>
+        </p:txBody>
+      </p:sp>
+      <p:sp>
+        <p:nvSpPr>
+          <p:cNvPr id="12" name="Rounded Rectangle 11"/>
+          <p:cNvSpPr/>
+          <p:nvPr/>
+        </p:nvSpPr>
+        <p:spPr>
+          <a:xfrm>
+            <a:off x="777240" y="3273552"/>
+            <a:ext cx="3886200" cy="1188720"/>
+          </a:xfrm>
+          <a:prstGeom prst="roundRect">
+            <a:avLst/>
+          </a:prstGeom>
+          <a:solidFill>
+            <a:srgbClr val="F7F3EE"/>
+          </a:solidFill>
+          <a:ln w="15240">
+            <a:solidFill>
+              <a:srgbClr val="D6CCC1"/>
+            </a:solidFill>
+          </a:ln>
+        </p:spPr>
+        <p:style>
+          <a:lnRef idx="1">
+            <a:schemeClr val="accent1"/>
+          </a:lnRef>
+          <a:fillRef idx="3">
+            <a:schemeClr val="accent1"/>
+          </a:fillRef>
+          <a:effectRef idx="2">
+            <a:schemeClr val="accent1"/>
+          </a:effectRef>
+          <a:fontRef idx="minor">
+            <a:schemeClr val="lt1"/>
+          </a:fontRef>
+        </p:style>
+        <p:txBody>
+          <a:bodyPr rtlCol="0" anchor="ctr"/>
+          <a:lstStyle/>
+          <a:p>
+            <a:pPr algn="ctr"/>
+          </a:p>
+        </p:txBody>
+      </p:sp>
+      <p:sp>
+        <p:nvSpPr>
+          <p:cNvPr id="13" name="Rectangle 12"/>
+          <p:cNvSpPr/>
+          <p:nvPr/>
+        </p:nvSpPr>
+        <p:spPr>
+          <a:xfrm>
+            <a:off x="777240" y="3273552"/>
+            <a:ext cx="118872" cy="1188720"/>
+          </a:xfrm>
+          <a:prstGeom prst="rect">
+            <a:avLst/>
+          </a:prstGeom>
+          <a:solidFill>
+            <a:srgbClr val="54B9D6"/>
+          </a:solidFill>
+          <a:ln>
+            <a:noFill/>
+          </a:ln>
+        </p:spPr>
+        <p:style>
+          <a:lnRef idx="1">
+            <a:schemeClr val="accent1"/>
+          </a:lnRef>
+          <a:fillRef idx="3">
+            <a:schemeClr val="accent1"/>
+          </a:fillRef>
+          <a:effectRef idx="2">
+            <a:schemeClr val="accent1"/>
+          </a:effectRef>
+          <a:fontRef idx="minor">
+            <a:schemeClr val="lt1"/>
+          </a:fontRef>
+        </p:style>
+        <p:txBody>
+          <a:bodyPr rtlCol="0" anchor="ctr"/>
+          <a:lstStyle/>
+          <a:p>
+            <a:pPr algn="ctr"/>
+          </a:p>
+        </p:txBody>
+      </p:sp>
+      <p:sp>
+        <p:nvSpPr>
+          <p:cNvPr id="14" name="TextBox 13"/>
+          <p:cNvSpPr txBox="1"/>
+          <p:nvPr/>
+        </p:nvSpPr>
+        <p:spPr>
+          <a:xfrm>
+            <a:off x="1033272" y="3456432"/>
+            <a:ext cx="3429000" cy="914400"/>
+          </a:xfrm>
+          <a:prstGeom prst="rect">
+            <a:avLst/>
+          </a:prstGeom>
+          <a:noFill/>
+        </p:spPr>
+        <p:txBody>
+          <a:bodyPr wrap="square">
+            <a:spAutoFit/>
+          </a:bodyPr>
+          <a:lstStyle/>
+          <a:p>
+            <a:pPr>
+              <a:spcAft>
+                <a:spcPts val="200"/>
+              </a:spcAft>
+            </a:pPr>
+            <a:r>
+              <a:rPr sz="1400" b="1">
+                <a:solidFill>
+                  <a:srgbClr val="19212A"/>
+                </a:solidFill>
+                <a:latin typeface="Aptos Display"/>
+              </a:rPr>
+              <a:t>Why this matters</a:t>
+            </a:r>
+          </a:p>
+          <a:p>
+            <a:r>
+              <a:rPr sz="1100" b="0">
+                <a:solidFill>
+                  <a:srgbClr val="57606D"/>
+                </a:solidFill>
+                <a:latin typeface="Aptos"/>
+              </a:rPr>
+              <a:t>The point is not that AGILAB ran somewhere. The point is that it ended on visible evidence a reviewer can inspect.</a:t>
+            </a:r>
+          </a:p>
+        </p:txBody>
+      </p:sp>
+      <p:sp>
+        <p:nvSpPr>
+          <p:cNvPr id="15" name="Rounded Rectangle 14"/>
+          <p:cNvSpPr/>
+          <p:nvPr/>
+        </p:nvSpPr>
+        <p:spPr>
+          <a:xfrm>
+            <a:off x="777240" y="4800600"/>
+            <a:ext cx="1371600" cy="310896"/>
+          </a:xfrm>
+          <a:prstGeom prst="roundRect">
+            <a:avLst/>
+          </a:prstGeom>
+          <a:solidFill>
+            <a:srgbClr val="F5BF5B"/>
+          </a:solidFill>
+          <a:ln>
+            <a:noFill/>
+          </a:ln>
+        </p:spPr>
+        <p:style>
+          <a:lnRef idx="1">
+            <a:schemeClr val="accent1"/>
+          </a:lnRef>
+          <a:fillRef idx="3">
+            <a:schemeClr val="accent1"/>
+          </a:fillRef>
+          <a:effectRef idx="2">
+            <a:schemeClr val="accent1"/>
+          </a:effectRef>
+          <a:fontRef idx="minor">
+            <a:schemeClr val="lt1"/>
+          </a:fontRef>
+        </p:style>
+        <p:txBody>
+          <a:bodyPr rtlCol="0" anchor="ctr" wrap="none"/>
+          <a:lstStyle/>
+          <a:p>
+            <a:pPr algn="ctr"/>
+            <a:r>
+              <a:rPr sz="900" b="1">
+                <a:solidFill>
+                  <a:srgbClr val="19212A"/>
+                </a:solidFill>
+                <a:latin typeface="Aptos"/>
+              </a:rPr>
+              <a:t>VISIBLE RESULT</a:t>
+            </a:r>
+          </a:p>
+        </p:txBody>
+      </p:sp>
+      <p:sp>
+        <p:nvSpPr>
+          <p:cNvPr id="16" name="Rounded Rectangle 15"/>
+          <p:cNvSpPr/>
+          <p:nvPr/>
+        </p:nvSpPr>
+        <p:spPr>
+          <a:xfrm>
+            <a:off x="777240" y="5193792"/>
+            <a:ext cx="4206240" cy="786384"/>
+          </a:xfrm>
+          <a:prstGeom prst="roundRect">
+            <a:avLst/>
+          </a:prstGeom>
+          <a:solidFill>
+            <a:srgbClr val="1C2D3D"/>
+          </a:solidFill>
+          <a:ln w="15240">
+            <a:noFill/>
+          </a:ln>
+        </p:spPr>
+        <p:style>
+          <a:lnRef idx="1">
+            <a:schemeClr val="accent1"/>
+          </a:lnRef>
+          <a:fillRef idx="3">
+            <a:schemeClr val="accent1"/>
+          </a:fillRef>
+          <a:effectRef idx="2">
+            <a:schemeClr val="accent1"/>
+          </a:effectRef>
+          <a:fontRef idx="minor">
+            <a:schemeClr val="lt1"/>
+          </a:fontRef>
+        </p:style>
+        <p:txBody>
+          <a:bodyPr rtlCol="0" anchor="ctr"/>
+          <a:lstStyle/>
+          <a:p>
+            <a:pPr algn="ctr"/>
+          </a:p>
+        </p:txBody>
+      </p:sp>
+      <p:sp>
+        <p:nvSpPr>
+          <p:cNvPr id="17" name="TextBox 16"/>
+          <p:cNvSpPr txBox="1"/>
+          <p:nvPr/>
+        </p:nvSpPr>
+        <p:spPr>
+          <a:xfrm>
+            <a:off x="996696" y="5358384"/>
+            <a:ext cx="3767328" cy="566928"/>
+          </a:xfrm>
+          <a:prstGeom prst="rect">
+            <a:avLst/>
+          </a:prstGeom>
+          <a:noFill/>
+        </p:spPr>
+        <p:txBody>
+          <a:bodyPr wrap="square">
+            <a:spAutoFit/>
+          </a:bodyPr>
+          <a:lstStyle/>
+          <a:p>
+            <a:r>
+              <a:rPr sz="1200" b="0">
+                <a:solidFill>
+                  <a:srgbClr val="F4F0EB"/>
+                </a:solidFill>
+                <a:latin typeface="Aptos"/>
+              </a:rPr>
+              <a:t>Close the story on the result screen. That is what makes the first proof credible in one glance.</a:t>
+            </a:r>
+          </a:p>
+        </p:txBody>
+      </p:sp>
+      <p:sp>
+        <p:nvSpPr>
+          <p:cNvPr id="18" name="Rounded Rectangle 17"/>
+          <p:cNvSpPr/>
+          <p:nvPr/>
+        </p:nvSpPr>
+        <p:spPr>
+          <a:xfrm>
+            <a:off x="5321808" y="1399032"/>
+            <a:ext cx="5989320" cy="4526280"/>
+          </a:xfrm>
+          <a:prstGeom prst="roundRect">
+            <a:avLst/>
+          </a:prstGeom>
+          <a:solidFill>
+            <a:srgbClr val="12202D"/>
+          </a:solidFill>
+          <a:ln>
+            <a:noFill/>
+          </a:ln>
+        </p:spPr>
+        <p:style>
+          <a:lnRef idx="1">
+            <a:schemeClr val="accent1"/>
+          </a:lnRef>
+          <a:fillRef idx="3">
+            <a:schemeClr val="accent1"/>
+          </a:fillRef>
+          <a:effectRef idx="2">
+            <a:schemeClr val="accent1"/>
+          </a:effectRef>
+          <a:fontRef idx="minor">
+            <a:schemeClr val="lt1"/>
+          </a:fontRef>
+        </p:style>
+        <p:txBody>
+          <a:bodyPr rtlCol="0" anchor="ctr"/>
+          <a:lstStyle/>
+          <a:p>
+            <a:pPr algn="ctr"/>
+          </a:p>
+        </p:txBody>
+      </p:sp>
+      <p:sp>
+        <p:nvSpPr>
+          <p:cNvPr id="19" name="Rounded Rectangle 18"/>
+          <p:cNvSpPr/>
+          <p:nvPr/>
+        </p:nvSpPr>
+        <p:spPr>
+          <a:xfrm>
+            <a:off x="5257800" y="1325880"/>
+            <a:ext cx="5989320" cy="4526280"/>
+          </a:xfrm>
+          <a:prstGeom prst="roundRect">
+            <a:avLst/>
+          </a:prstGeom>
+          <a:solidFill>
+            <a:srgbClr val="F7F3EE"/>
+          </a:solidFill>
+          <a:ln w="15240">
+            <a:solidFill>
+              <a:srgbClr val="D6CCC1"/>
+            </a:solidFill>
+          </a:ln>
+        </p:spPr>
+        <p:style>
+          <a:lnRef idx="1">
+            <a:schemeClr val="accent1"/>
+          </a:lnRef>
+          <a:fillRef idx="3">
+            <a:schemeClr val="accent1"/>
+          </a:fillRef>
+          <a:effectRef idx="2">
+            <a:schemeClr val="accent1"/>
+          </a:effectRef>
+          <a:fontRef idx="minor">
+            <a:schemeClr val="lt1"/>
+          </a:fontRef>
+        </p:style>
+        <p:txBody>
+          <a:bodyPr rtlCol="0" anchor="ctr"/>
+          <a:lstStyle/>
+          <a:p>
+            <a:pPr algn="ctr"/>
           </a:p>
         </p:txBody>
       </p:sp>
       <p:pic>
         <p:nvPicPr>
-          <p:cNvPr id="3" name="Picture 2" descr="analysis-page.png"/>
+          <p:cNvPr id="20" name="Picture 19" descr="image.png"/>
           <p:cNvPicPr>
             <a:picLocks noChangeAspect="1"/>
           </p:cNvPicPr>
@@ -3864,8 +7353,8 @@
         </p:blipFill>
         <p:spPr>
           <a:xfrm>
-            <a:off x="822960" y="1325880"/>
-            <a:ext cx="10515600" cy="3886200"/>
+            <a:off x="5367528" y="1435608"/>
+            <a:ext cx="5769864" cy="4306824"/>
           </a:xfrm>
           <a:prstGeom prst="rect">
             <a:avLst/>
@@ -3874,25 +7363,23 @@
       </p:pic>
       <p:sp>
         <p:nvSpPr>
-          <p:cNvPr id="4" name="Rounded Rectangle 3"/>
+          <p:cNvPr id="21" name="Rounded Rectangle 20"/>
           <p:cNvSpPr/>
           <p:nvPr/>
         </p:nvSpPr>
         <p:spPr>
           <a:xfrm>
-            <a:off x="640080" y="5440680"/>
-            <a:ext cx="10972800" cy="777240"/>
+            <a:off x="5440680" y="1179576"/>
+            <a:ext cx="1097280" cy="310896"/>
           </a:xfrm>
           <a:prstGeom prst="roundRect">
             <a:avLst/>
           </a:prstGeom>
           <a:solidFill>
-            <a:srgbClr val="FFFBF5"/>
-          </a:solidFill>
-          <a:ln w="19050">
-            <a:solidFill>
-              <a:srgbClr val="DCCEBF"/>
-            </a:solidFill>
+            <a:srgbClr val="F5BF5B"/>
+          </a:solidFill>
+          <a:ln>
+            <a:noFill/>
           </a:ln>
         </p:spPr>
         <p:style>
@@ -3910,23 +7397,32 @@
           </a:fontRef>
         </p:style>
         <p:txBody>
-          <a:bodyPr rtlCol="0" anchor="ctr"/>
+          <a:bodyPr rtlCol="0" anchor="ctr" wrap="none"/>
           <a:lstStyle/>
           <a:p>
             <a:pPr algn="ctr"/>
-          </a:p>
-        </p:txBody>
-      </p:sp>
-      <p:sp>
-        <p:nvSpPr>
-          <p:cNvPr id="5" name="TextBox 4"/>
+            <a:r>
+              <a:rPr sz="900" b="1">
+                <a:solidFill>
+                  <a:srgbClr val="F4F0EB"/>
+                </a:solidFill>
+                <a:latin typeface="Aptos"/>
+              </a:rPr>
+              <a:t>ANALYSIS</a:t>
+            </a:r>
+          </a:p>
+        </p:txBody>
+      </p:sp>
+      <p:sp>
+        <p:nvSpPr>
+          <p:cNvPr id="22" name="TextBox 21"/>
           <p:cNvSpPr txBox="1"/>
           <p:nvPr/>
         </p:nvSpPr>
         <p:spPr>
           <a:xfrm>
-            <a:off x="914400" y="5596128"/>
-            <a:ext cx="10332720" cy="411480"/>
+            <a:off x="5422392" y="5468112"/>
+            <a:ext cx="5660136" cy="201168"/>
           </a:xfrm>
           <a:prstGeom prst="rect">
             <a:avLst/>
@@ -3934,23 +7430,19 @@
           <a:noFill/>
         </p:spPr>
         <p:txBody>
-          <a:bodyPr wrap="square">
+          <a:bodyPr wrap="none">
             <a:spAutoFit/>
           </a:bodyPr>
           <a:lstStyle/>
           <a:p>
-            <a:pPr>
-              <a:spcAft>
-                <a:spcPts val="800"/>
-              </a:spcAft>
-              <a:defRPr sz="1800">
+            <a:r>
+              <a:rPr sz="1000" b="1">
                 <a:solidFill>
-                  <a:srgbClr val="212427"/>
+                  <a:srgbClr val="F4F0EB"/>
                 </a:solidFill>
-              </a:defRPr>
-            </a:pPr>
-            <a:r>
-              <a:t>Close the deck on visible output: the point is not just that AGILAB ran, but that it landed on a readable result.</a:t>
+                <a:latin typeface="Aptos"/>
+              </a:rPr>
+              <a:t>Readable result screen, centered as the payoff of the first proof.</a:t>
             </a:r>
           </a:p>
         </p:txBody>

</xml_diff>